<commit_message>
Record playback engine ADR contracts
</commit_message>
<xml_diff>
--- a/MiniEditorCoexistence/docs/Timeline-Playback-Engine-Learning.pptx
+++ b/MiniEditorCoexistence/docs/Timeline-Playback-Engine-Learning.pptx
@@ -2,18 +2,18 @@
 <file path=ppt/presentation.xml><?xml version="1.0" encoding="utf-8"?>
 <p:presentation xmlns:p="http://schemas.openxmlformats.org/presentationml/2006/main">
   <p:sldMasterIdLst>
-    <p:sldMasterId xmlns:r="http://schemas.openxmlformats.org/officeDocument/2006/relationships" id="2147483648" r:id="R7d8f3930fdb7451d"/>
+    <p:sldMasterId xmlns:r="http://schemas.openxmlformats.org/officeDocument/2006/relationships" id="2147483648" r:id="Raac93b11c8a84f4e"/>
   </p:sldMasterIdLst>
   <p:notesMasterIdLst>
-    <p:notesMasterId xmlns:r="http://schemas.openxmlformats.org/officeDocument/2006/relationships" r:id="R5b53eb806bc74f87"/>
+    <p:notesMasterId xmlns:r="http://schemas.openxmlformats.org/officeDocument/2006/relationships" r:id="Ra1cc336f57c14a62"/>
   </p:notesMasterIdLst>
   <p:sldIdLst>
-    <p:sldId xmlns:r="http://schemas.openxmlformats.org/officeDocument/2006/relationships" id="256" r:id="R843cec3b67ed469f"/>
-    <p:sldId xmlns:r="http://schemas.openxmlformats.org/officeDocument/2006/relationships" id="257" r:id="Rd9a023a4482d4c26"/>
-    <p:sldId xmlns:r="http://schemas.openxmlformats.org/officeDocument/2006/relationships" id="258" r:id="R20c8422350dd482d"/>
-    <p:sldId xmlns:r="http://schemas.openxmlformats.org/officeDocument/2006/relationships" id="259" r:id="R065f130c0b8648fb"/>
-    <p:sldId xmlns:r="http://schemas.openxmlformats.org/officeDocument/2006/relationships" id="260" r:id="R4d6ac88b0d5942f9"/>
-    <p:sldId xmlns:r="http://schemas.openxmlformats.org/officeDocument/2006/relationships" id="261" r:id="R554665d5de8548bb"/>
+    <p:sldId xmlns:r="http://schemas.openxmlformats.org/officeDocument/2006/relationships" id="256" r:id="R7341411fe8ed4de9"/>
+    <p:sldId xmlns:r="http://schemas.openxmlformats.org/officeDocument/2006/relationships" id="257" r:id="Rc27900ce56e14e47"/>
+    <p:sldId xmlns:r="http://schemas.openxmlformats.org/officeDocument/2006/relationships" id="258" r:id="R4e9c0bd86816485b"/>
+    <p:sldId xmlns:r="http://schemas.openxmlformats.org/officeDocument/2006/relationships" id="259" r:id="Rf156b321451744b2"/>
+    <p:sldId xmlns:r="http://schemas.openxmlformats.org/officeDocument/2006/relationships" id="260" r:id="Rc0b258debaf34b50"/>
+    <p:sldId xmlns:r="http://schemas.openxmlformats.org/officeDocument/2006/relationships" id="261" r:id="Ra306bb9c6d7c41e2"/>
   </p:sldIdLst>
   <p:sldSz cx="12192000" cy="6858000"/>
   <p:notesSz cx="6858000" cy="9144000"/>
@@ -920,7 +920,7 @@
   </p:cSld>
   <p:clrMap bg1="lt1" tx1="dk1" bg2="lt2" tx2="dk2" accent1="accent1" accent2="accent2" accent3="accent3" accent4="accent4" accent5="accent5" accent6="accent6" hlink="hlink" folHlink="folHlink"/>
   <p:sldLayoutIdLst>
-    <p:sldLayoutId xmlns:r="http://schemas.openxmlformats.org/officeDocument/2006/relationships" id="2147483649" r:id="R8c87984d36bb4941"/>
+    <p:sldLayoutId xmlns:r="http://schemas.openxmlformats.org/officeDocument/2006/relationships" id="2147483649" r:id="Rb616a9820bdd4b60"/>
   </p:sldLayoutIdLst>
   <p:txStyles>
     <p:titleStyle>
@@ -1499,6 +1499,7 @@
           <a:lstStyle xmlns:a="http://schemas.openxmlformats.org/drawingml/2006/main"/>
           <a:p xmlns:a="http://schemas.openxmlformats.org/drawingml/2006/main">
             <a:pPr algn="l">
+              <a:buNone/>
               <a:defRPr sz="1800" b="1">
                 <a:solidFill>
                   <a:srgbClr val="62666D"/>
@@ -1555,6 +1556,7 @@
           <a:lstStyle xmlns:a="http://schemas.openxmlformats.org/drawingml/2006/main"/>
           <a:p xmlns:a="http://schemas.openxmlformats.org/drawingml/2006/main">
             <a:pPr algn="l">
+              <a:buNone/>
               <a:defRPr sz="5850" b="1">
                 <a:solidFill>
                   <a:srgbClr val="000000"/>
@@ -1578,6 +1580,7 @@
           </a:p>
           <a:p xmlns:a="http://schemas.openxmlformats.org/drawingml/2006/main">
             <a:pPr algn="l">
+              <a:buNone/>
               <a:defRPr sz="5850" b="1">
                 <a:solidFill>
                   <a:srgbClr val="000000"/>
@@ -1634,6 +1637,7 @@
           <a:lstStyle xmlns:a="http://schemas.openxmlformats.org/drawingml/2006/main"/>
           <a:p xmlns:a="http://schemas.openxmlformats.org/drawingml/2006/main">
             <a:pPr algn="l">
+              <a:buNone/>
               <a:defRPr sz="2250" b="0">
                 <a:solidFill>
                   <a:srgbClr val="62666D"/>
@@ -1690,6 +1694,7 @@
           <a:lstStyle xmlns:a="http://schemas.openxmlformats.org/drawingml/2006/main"/>
           <a:p xmlns:a="http://schemas.openxmlformats.org/drawingml/2006/main">
             <a:pPr algn="l">
+              <a:buNone/>
               <a:defRPr sz="1500" b="1">
                 <a:solidFill>
                   <a:srgbClr val="3D8DFF"/>
@@ -1708,7 +1713,7 @@
                 <a:ea typeface="Arial"/>
                 <a:cs typeface="Arial"/>
               </a:rPr>
-              <a:t>Baseline · current-state map complete</a:t>
+              <a:t>ADR-001 accepted · strong media time domains</a:t>
             </a:r>
           </a:p>
         </p:txBody>
@@ -1775,6 +1780,7 @@
           <a:lstStyle xmlns:a="http://schemas.openxmlformats.org/drawingml/2006/main"/>
           <a:p xmlns:a="http://schemas.openxmlformats.org/drawingml/2006/main">
             <a:pPr algn="l">
+              <a:buNone/>
               <a:defRPr sz="3150" b="1">
                 <a:solidFill>
                   <a:srgbClr val="000000"/>
@@ -1862,6 +1868,7 @@
           <a:lstStyle xmlns:a="http://schemas.openxmlformats.org/drawingml/2006/main"/>
           <a:p xmlns:a="http://schemas.openxmlformats.org/drawingml/2006/main">
             <a:pPr algn="r">
+              <a:buNone/>
               <a:defRPr sz="1200" b="0">
                 <a:solidFill>
                   <a:srgbClr val="62666D"/>
@@ -1918,6 +1925,7 @@
           <a:lstStyle xmlns:a="http://schemas.openxmlformats.org/drawingml/2006/main"/>
           <a:p xmlns:a="http://schemas.openxmlformats.org/drawingml/2006/main">
             <a:pPr algn="l">
+              <a:buNone/>
               <a:defRPr sz="1875" b="1">
                 <a:solidFill>
                   <a:srgbClr val="3D8DFF"/>
@@ -1974,6 +1982,7 @@
           <a:lstStyle xmlns:a="http://schemas.openxmlformats.org/drawingml/2006/main"/>
           <a:p xmlns:a="http://schemas.openxmlformats.org/drawingml/2006/main">
             <a:pPr algn="l">
+              <a:buNone/>
               <a:defRPr sz="1875" b="0">
                 <a:solidFill>
                   <a:srgbClr val="000000"/>
@@ -2002,6 +2011,7 @@
           </a:p>
           <a:p xmlns:a="http://schemas.openxmlformats.org/drawingml/2006/main">
             <a:pPr algn="l">
+              <a:buNone/>
               <a:defRPr sz="1875" b="0">
                 <a:solidFill>
                   <a:srgbClr val="000000"/>
@@ -2030,6 +2040,7 @@
           </a:p>
           <a:p xmlns:a="http://schemas.openxmlformats.org/drawingml/2006/main">
             <a:pPr algn="l">
+              <a:buNone/>
               <a:defRPr sz="1875" b="0">
                 <a:solidFill>
                   <a:srgbClr val="000000"/>
@@ -2148,6 +2159,7 @@
           <a:lstStyle xmlns:a="http://schemas.openxmlformats.org/drawingml/2006/main"/>
           <a:p xmlns:a="http://schemas.openxmlformats.org/drawingml/2006/main">
             <a:pPr algn="l">
+              <a:buNone/>
               <a:defRPr sz="1875" b="1">
                 <a:solidFill>
                   <a:srgbClr val="3D8DFF"/>
@@ -2204,6 +2216,7 @@
           <a:lstStyle xmlns:a="http://schemas.openxmlformats.org/drawingml/2006/main"/>
           <a:p xmlns:a="http://schemas.openxmlformats.org/drawingml/2006/main">
             <a:pPr algn="l">
+              <a:buNone/>
               <a:defRPr sz="1875" b="0">
                 <a:solidFill>
                   <a:srgbClr val="000000"/>
@@ -2232,6 +2245,7 @@
           </a:p>
           <a:p xmlns:a="http://schemas.openxmlformats.org/drawingml/2006/main">
             <a:pPr algn="l">
+              <a:buNone/>
               <a:defRPr sz="1875" b="0">
                 <a:solidFill>
                   <a:srgbClr val="000000"/>
@@ -2260,6 +2274,7 @@
           </a:p>
           <a:p xmlns:a="http://schemas.openxmlformats.org/drawingml/2006/main">
             <a:pPr algn="l">
+              <a:buNone/>
               <a:defRPr sz="1875" b="0">
                 <a:solidFill>
                   <a:srgbClr val="000000"/>
@@ -2316,6 +2331,7 @@
           <a:lstStyle xmlns:a="http://schemas.openxmlformats.org/drawingml/2006/main"/>
           <a:p xmlns:a="http://schemas.openxmlformats.org/drawingml/2006/main">
             <a:pPr algn="l">
+              <a:buNone/>
               <a:defRPr sz="1875" b="1">
                 <a:solidFill>
                   <a:srgbClr val="000000"/>
@@ -2401,6 +2417,7 @@
           <a:lstStyle xmlns:a="http://schemas.openxmlformats.org/drawingml/2006/main"/>
           <a:p xmlns:a="http://schemas.openxmlformats.org/drawingml/2006/main">
             <a:pPr algn="l">
+              <a:buNone/>
               <a:defRPr sz="3150" b="1">
                 <a:solidFill>
                   <a:srgbClr val="000000"/>
@@ -2488,6 +2505,7 @@
           <a:lstStyle xmlns:a="http://schemas.openxmlformats.org/drawingml/2006/main"/>
           <a:p xmlns:a="http://schemas.openxmlformats.org/drawingml/2006/main">
             <a:pPr algn="r">
+              <a:buNone/>
               <a:defRPr sz="1200" b="0">
                 <a:solidFill>
                   <a:srgbClr val="62666D"/>
@@ -2680,6 +2698,7 @@
           <a:lstStyle xmlns:a="http://schemas.openxmlformats.org/drawingml/2006/main"/>
           <a:p xmlns:a="http://schemas.openxmlformats.org/drawingml/2006/main">
             <a:pPr algn="ctr">
+              <a:buNone/>
               <a:defRPr sz="1575" b="1">
                 <a:solidFill>
                   <a:srgbClr val="000000"/>
@@ -2703,6 +2722,7 @@
           </a:p>
           <a:p xmlns:a="http://schemas.openxmlformats.org/drawingml/2006/main">
             <a:pPr algn="ctr">
+              <a:buNone/>
               <a:defRPr sz="1575" b="1">
                 <a:solidFill>
                   <a:srgbClr val="000000"/>
@@ -2763,6 +2783,7 @@
           <a:lstStyle xmlns:a="http://schemas.openxmlformats.org/drawingml/2006/main"/>
           <a:p xmlns:a="http://schemas.openxmlformats.org/drawingml/2006/main">
             <a:pPr algn="ctr">
+              <a:buNone/>
               <a:defRPr sz="1575" b="1">
                 <a:solidFill>
                   <a:srgbClr val="000000"/>
@@ -2786,6 +2807,7 @@
           </a:p>
           <a:p xmlns:a="http://schemas.openxmlformats.org/drawingml/2006/main">
             <a:pPr algn="ctr">
+              <a:buNone/>
               <a:defRPr sz="1575" b="1">
                 <a:solidFill>
                   <a:srgbClr val="000000"/>
@@ -2846,6 +2868,7 @@
           <a:lstStyle xmlns:a="http://schemas.openxmlformats.org/drawingml/2006/main"/>
           <a:p xmlns:a="http://schemas.openxmlformats.org/drawingml/2006/main">
             <a:pPr algn="ctr">
+              <a:buNone/>
               <a:defRPr sz="1575" b="1">
                 <a:solidFill>
                   <a:srgbClr val="000000"/>
@@ -2869,6 +2892,7 @@
           </a:p>
           <a:p xmlns:a="http://schemas.openxmlformats.org/drawingml/2006/main">
             <a:pPr algn="ctr">
+              <a:buNone/>
               <a:defRPr sz="1575" b="1">
                 <a:solidFill>
                   <a:srgbClr val="000000"/>
@@ -2929,6 +2953,7 @@
           <a:lstStyle xmlns:a="http://schemas.openxmlformats.org/drawingml/2006/main"/>
           <a:p xmlns:a="http://schemas.openxmlformats.org/drawingml/2006/main">
             <a:pPr algn="ctr">
+              <a:buNone/>
               <a:defRPr sz="1575" b="1">
                 <a:solidFill>
                   <a:srgbClr val="000000"/>
@@ -2952,6 +2977,7 @@
           </a:p>
           <a:p xmlns:a="http://schemas.openxmlformats.org/drawingml/2006/main">
             <a:pPr algn="ctr">
+              <a:buNone/>
               <a:defRPr sz="1575" b="1">
                 <a:solidFill>
                   <a:srgbClr val="000000"/>
@@ -3012,6 +3038,7 @@
           <a:lstStyle xmlns:a="http://schemas.openxmlformats.org/drawingml/2006/main"/>
           <a:p xmlns:a="http://schemas.openxmlformats.org/drawingml/2006/main">
             <a:pPr algn="ctr">
+              <a:buNone/>
               <a:defRPr sz="1575" b="1">
                 <a:solidFill>
                   <a:srgbClr val="000000"/>
@@ -3035,6 +3062,7 @@
           </a:p>
           <a:p xmlns:a="http://schemas.openxmlformats.org/drawingml/2006/main">
             <a:pPr algn="ctr">
+              <a:buNone/>
               <a:defRPr sz="1575" b="1">
                 <a:solidFill>
                   <a:srgbClr val="000000"/>
@@ -3091,6 +3119,7 @@
           <a:lstStyle xmlns:a="http://schemas.openxmlformats.org/drawingml/2006/main"/>
           <a:p xmlns:a="http://schemas.openxmlformats.org/drawingml/2006/main">
             <a:pPr algn="ctr">
+              <a:buNone/>
               <a:defRPr sz="1500" b="0">
                 <a:solidFill>
                   <a:srgbClr val="62666D"/>
@@ -3147,6 +3176,7 @@
           <a:lstStyle xmlns:a="http://schemas.openxmlformats.org/drawingml/2006/main"/>
           <a:p xmlns:a="http://schemas.openxmlformats.org/drawingml/2006/main">
             <a:pPr algn="ctr">
+              <a:buNone/>
               <a:defRPr sz="1500" b="0">
                 <a:solidFill>
                   <a:srgbClr val="62666D"/>
@@ -3203,6 +3233,7 @@
           <a:lstStyle xmlns:a="http://schemas.openxmlformats.org/drawingml/2006/main"/>
           <a:p xmlns:a="http://schemas.openxmlformats.org/drawingml/2006/main">
             <a:pPr algn="ctr">
+              <a:buNone/>
               <a:defRPr sz="1500" b="0">
                 <a:solidFill>
                   <a:srgbClr val="62666D"/>
@@ -3259,6 +3290,7 @@
           <a:lstStyle xmlns:a="http://schemas.openxmlformats.org/drawingml/2006/main"/>
           <a:p xmlns:a="http://schemas.openxmlformats.org/drawingml/2006/main">
             <a:pPr algn="ctr">
+              <a:buNone/>
               <a:defRPr sz="2100" b="1">
                 <a:solidFill>
                   <a:srgbClr val="000000"/>
@@ -3344,6 +3376,7 @@
           <a:lstStyle xmlns:a="http://schemas.openxmlformats.org/drawingml/2006/main"/>
           <a:p xmlns:a="http://schemas.openxmlformats.org/drawingml/2006/main">
             <a:pPr algn="l">
+              <a:buNone/>
               <a:defRPr sz="3150" b="1">
                 <a:solidFill>
                   <a:srgbClr val="000000"/>
@@ -3431,6 +3464,7 @@
           <a:lstStyle xmlns:a="http://schemas.openxmlformats.org/drawingml/2006/main"/>
           <a:p xmlns:a="http://schemas.openxmlformats.org/drawingml/2006/main">
             <a:pPr algn="r">
+              <a:buNone/>
               <a:defRPr sz="1200" b="0">
                 <a:solidFill>
                   <a:srgbClr val="62666D"/>
@@ -3656,6 +3690,7 @@
           <a:lstStyle xmlns:a="http://schemas.openxmlformats.org/drawingml/2006/main"/>
           <a:p xmlns:a="http://schemas.openxmlformats.org/drawingml/2006/main">
             <a:pPr algn="ctr">
+              <a:buNone/>
               <a:defRPr sz="1575" b="1">
                 <a:solidFill>
                   <a:srgbClr val="000000"/>
@@ -3679,6 +3714,7 @@
           </a:p>
           <a:p xmlns:a="http://schemas.openxmlformats.org/drawingml/2006/main">
             <a:pPr algn="ctr">
+              <a:buNone/>
               <a:defRPr sz="1575" b="1">
                 <a:solidFill>
                   <a:srgbClr val="000000"/>
@@ -3739,6 +3775,7 @@
           <a:lstStyle xmlns:a="http://schemas.openxmlformats.org/drawingml/2006/main"/>
           <a:p xmlns:a="http://schemas.openxmlformats.org/drawingml/2006/main">
             <a:pPr algn="ctr">
+              <a:buNone/>
               <a:defRPr sz="1575" b="1">
                 <a:solidFill>
                   <a:srgbClr val="000000"/>
@@ -3762,6 +3799,7 @@
           </a:p>
           <a:p xmlns:a="http://schemas.openxmlformats.org/drawingml/2006/main">
             <a:pPr algn="ctr">
+              <a:buNone/>
               <a:defRPr sz="1575" b="1">
                 <a:solidFill>
                   <a:srgbClr val="000000"/>
@@ -3822,6 +3860,7 @@
           <a:lstStyle xmlns:a="http://schemas.openxmlformats.org/drawingml/2006/main"/>
           <a:p xmlns:a="http://schemas.openxmlformats.org/drawingml/2006/main">
             <a:pPr algn="ctr">
+              <a:buNone/>
               <a:defRPr sz="1575" b="1">
                 <a:solidFill>
                   <a:srgbClr val="000000"/>
@@ -3845,6 +3884,7 @@
           </a:p>
           <a:p xmlns:a="http://schemas.openxmlformats.org/drawingml/2006/main">
             <a:pPr algn="ctr">
+              <a:buNone/>
               <a:defRPr sz="1575" b="1">
                 <a:solidFill>
                   <a:srgbClr val="000000"/>
@@ -3905,6 +3945,7 @@
           <a:lstStyle xmlns:a="http://schemas.openxmlformats.org/drawingml/2006/main"/>
           <a:p xmlns:a="http://schemas.openxmlformats.org/drawingml/2006/main">
             <a:pPr algn="ctr">
+              <a:buNone/>
               <a:defRPr sz="1575" b="1">
                 <a:solidFill>
                   <a:srgbClr val="FFFFFF"/>
@@ -3928,6 +3969,7 @@
           </a:p>
           <a:p xmlns:a="http://schemas.openxmlformats.org/drawingml/2006/main">
             <a:pPr algn="ctr">
+              <a:buNone/>
               <a:defRPr sz="1575" b="1">
                 <a:solidFill>
                   <a:srgbClr val="FFFFFF"/>
@@ -3988,6 +4030,7 @@
           <a:lstStyle xmlns:a="http://schemas.openxmlformats.org/drawingml/2006/main"/>
           <a:p xmlns:a="http://schemas.openxmlformats.org/drawingml/2006/main">
             <a:pPr algn="ctr">
+              <a:buNone/>
               <a:defRPr sz="1575" b="1">
                 <a:solidFill>
                   <a:srgbClr val="000000"/>
@@ -4011,6 +4054,7 @@
           </a:p>
           <a:p xmlns:a="http://schemas.openxmlformats.org/drawingml/2006/main">
             <a:pPr algn="ctr">
+              <a:buNone/>
               <a:defRPr sz="1575" b="1">
                 <a:solidFill>
                   <a:srgbClr val="000000"/>
@@ -4071,6 +4115,7 @@
           <a:lstStyle xmlns:a="http://schemas.openxmlformats.org/drawingml/2006/main"/>
           <a:p xmlns:a="http://schemas.openxmlformats.org/drawingml/2006/main">
             <a:pPr algn="ctr">
+              <a:buNone/>
               <a:defRPr sz="1575" b="1">
                 <a:solidFill>
                   <a:srgbClr val="000000"/>
@@ -4094,6 +4139,7 @@
           </a:p>
           <a:p xmlns:a="http://schemas.openxmlformats.org/drawingml/2006/main">
             <a:pPr algn="ctr">
+              <a:buNone/>
               <a:defRPr sz="1575" b="1">
                 <a:solidFill>
                   <a:srgbClr val="000000"/>
@@ -4150,6 +4196,7 @@
           <a:lstStyle xmlns:a="http://schemas.openxmlformats.org/drawingml/2006/main"/>
           <a:p xmlns:a="http://schemas.openxmlformats.org/drawingml/2006/main">
             <a:pPr algn="ctr">
+              <a:buNone/>
               <a:defRPr sz="2175" b="1">
                 <a:solidFill>
                   <a:srgbClr val="000000"/>
@@ -4235,6 +4282,7 @@
           <a:lstStyle xmlns:a="http://schemas.openxmlformats.org/drawingml/2006/main"/>
           <a:p xmlns:a="http://schemas.openxmlformats.org/drawingml/2006/main">
             <a:pPr algn="l">
+              <a:buNone/>
               <a:defRPr sz="3150" b="1">
                 <a:solidFill>
                   <a:srgbClr val="000000"/>
@@ -4322,6 +4370,7 @@
           <a:lstStyle xmlns:a="http://schemas.openxmlformats.org/drawingml/2006/main"/>
           <a:p xmlns:a="http://schemas.openxmlformats.org/drawingml/2006/main">
             <a:pPr algn="r">
+              <a:buNone/>
               <a:defRPr sz="1200" b="0">
                 <a:solidFill>
                   <a:srgbClr val="62666D"/>
@@ -4378,6 +4427,7 @@
           <a:lstStyle xmlns:a="http://schemas.openxmlformats.org/drawingml/2006/main"/>
           <a:p xmlns:a="http://schemas.openxmlformats.org/drawingml/2006/main">
             <a:pPr algn="l">
+              <a:buNone/>
               <a:defRPr sz="1875" b="1">
                 <a:solidFill>
                   <a:srgbClr val="3D8DFF"/>
@@ -4434,6 +4484,7 @@
           <a:lstStyle xmlns:a="http://schemas.openxmlformats.org/drawingml/2006/main"/>
           <a:p xmlns:a="http://schemas.openxmlformats.org/drawingml/2006/main">
             <a:pPr algn="l">
+              <a:buNone/>
               <a:defRPr sz="1875" b="0">
                 <a:solidFill>
                   <a:srgbClr val="000000"/>
@@ -4490,6 +4541,7 @@
           <a:lstStyle xmlns:a="http://schemas.openxmlformats.org/drawingml/2006/main"/>
           <a:p xmlns:a="http://schemas.openxmlformats.org/drawingml/2006/main">
             <a:pPr algn="l">
+              <a:buNone/>
               <a:defRPr sz="1875" b="1">
                 <a:solidFill>
                   <a:srgbClr val="3D8DFF"/>
@@ -4546,6 +4598,7 @@
           <a:lstStyle xmlns:a="http://schemas.openxmlformats.org/drawingml/2006/main"/>
           <a:p xmlns:a="http://schemas.openxmlformats.org/drawingml/2006/main">
             <a:pPr algn="l">
+              <a:buNone/>
               <a:defRPr sz="1875" b="0">
                 <a:solidFill>
                   <a:srgbClr val="000000"/>
@@ -4602,6 +4655,7 @@
           <a:lstStyle xmlns:a="http://schemas.openxmlformats.org/drawingml/2006/main"/>
           <a:p xmlns:a="http://schemas.openxmlformats.org/drawingml/2006/main">
             <a:pPr algn="l">
+              <a:buNone/>
               <a:defRPr sz="1875" b="1">
                 <a:solidFill>
                   <a:srgbClr val="3D8DFF"/>
@@ -4658,6 +4712,7 @@
           <a:lstStyle xmlns:a="http://schemas.openxmlformats.org/drawingml/2006/main"/>
           <a:p xmlns:a="http://schemas.openxmlformats.org/drawingml/2006/main">
             <a:pPr algn="l">
+              <a:buNone/>
               <a:defRPr sz="1875" b="0">
                 <a:solidFill>
                   <a:srgbClr val="000000"/>
@@ -4714,6 +4769,7 @@
           <a:lstStyle xmlns:a="http://schemas.openxmlformats.org/drawingml/2006/main"/>
           <a:p xmlns:a="http://schemas.openxmlformats.org/drawingml/2006/main">
             <a:pPr algn="l">
+              <a:buNone/>
               <a:defRPr sz="1875" b="1">
                 <a:solidFill>
                   <a:srgbClr val="3D8DFF"/>
@@ -4770,6 +4826,7 @@
           <a:lstStyle xmlns:a="http://schemas.openxmlformats.org/drawingml/2006/main"/>
           <a:p xmlns:a="http://schemas.openxmlformats.org/drawingml/2006/main">
             <a:pPr algn="l">
+              <a:buNone/>
               <a:defRPr sz="1875" b="0">
                 <a:solidFill>
                   <a:srgbClr val="000000"/>
@@ -4855,6 +4912,7 @@
           <a:lstStyle xmlns:a="http://schemas.openxmlformats.org/drawingml/2006/main"/>
           <a:p xmlns:a="http://schemas.openxmlformats.org/drawingml/2006/main">
             <a:pPr algn="l">
+              <a:buNone/>
               <a:defRPr sz="3150" b="1">
                 <a:solidFill>
                   <a:srgbClr val="000000"/>
@@ -4942,6 +5000,7 @@
           <a:lstStyle xmlns:a="http://schemas.openxmlformats.org/drawingml/2006/main"/>
           <a:p xmlns:a="http://schemas.openxmlformats.org/drawingml/2006/main">
             <a:pPr algn="r">
+              <a:buNone/>
               <a:defRPr sz="1200" b="0">
                 <a:solidFill>
                   <a:srgbClr val="62666D"/>
@@ -5128,6 +5187,7 @@
           <a:lstStyle xmlns:a="http://schemas.openxmlformats.org/drawingml/2006/main"/>
           <a:p xmlns:a="http://schemas.openxmlformats.org/drawingml/2006/main">
             <a:pPr algn="l">
+              <a:buNone/>
               <a:defRPr sz="1500" b="1">
                 <a:solidFill>
                   <a:srgbClr val="62666D"/>
@@ -5146,7 +5206,7 @@
                 <a:ea typeface="Arial"/>
                 <a:cs typeface="Arial"/>
               </a:rPr>
-              <a:t>NOW</a:t>
+              <a:t>ACCEPTED</a:t>
             </a:r>
           </a:p>
         </p:txBody>
@@ -5184,6 +5244,7 @@
           <a:lstStyle xmlns:a="http://schemas.openxmlformats.org/drawingml/2006/main"/>
           <a:p xmlns:a="http://schemas.openxmlformats.org/drawingml/2006/main">
             <a:pPr algn="l">
+              <a:buNone/>
               <a:defRPr sz="1500" b="1">
                 <a:solidFill>
                   <a:srgbClr val="62666D"/>
@@ -5240,6 +5301,7 @@
           <a:lstStyle xmlns:a="http://schemas.openxmlformats.org/drawingml/2006/main"/>
           <a:p xmlns:a="http://schemas.openxmlformats.org/drawingml/2006/main">
             <a:pPr algn="l">
+              <a:buNone/>
               <a:defRPr sz="1500" b="1">
                 <a:solidFill>
                   <a:srgbClr val="62666D"/>
@@ -5296,6 +5358,7 @@
           <a:lstStyle xmlns:a="http://schemas.openxmlformats.org/drawingml/2006/main"/>
           <a:p xmlns:a="http://schemas.openxmlformats.org/drawingml/2006/main">
             <a:pPr algn="l">
+              <a:buNone/>
               <a:defRPr sz="2025" b="1">
                 <a:solidFill>
                   <a:srgbClr val="000000"/>
@@ -5314,7 +5377,7 @@
                 <a:ea typeface="Arial"/>
                 <a:cs typeface="Arial"/>
               </a:rPr>
-              <a:t>Contracts</a:t>
+              <a:t>Time contracts</a:t>
             </a:r>
           </a:p>
         </p:txBody>
@@ -5352,6 +5415,7 @@
           <a:lstStyle xmlns:a="http://schemas.openxmlformats.org/drawingml/2006/main"/>
           <a:p xmlns:a="http://schemas.openxmlformats.org/drawingml/2006/main">
             <a:pPr algn="l">
+              <a:buNone/>
               <a:defRPr sz="1725" b="0">
                 <a:solidFill>
                   <a:srgbClr val="000000"/>
@@ -5370,11 +5434,12 @@
                 <a:ea typeface="Arial"/>
                 <a:cs typeface="Arial"/>
               </a:rPr>
-              <a:t>Time types</a:t>
+              <a:t>ADR-001 accepted</a:t>
             </a:r>
           </a:p>
           <a:p xmlns:a="http://schemas.openxmlformats.org/drawingml/2006/main">
             <a:pPr algn="l">
+              <a:buNone/>
               <a:defRPr sz="1725" b="0">
                 <a:solidFill>
                   <a:srgbClr val="000000"/>
@@ -5393,11 +5458,12 @@
                 <a:ea typeface="Arial"/>
                 <a:cs typeface="Arial"/>
               </a:rPr>
-              <a:t>Sequences</a:t>
+              <a:t>8 strong types</a:t>
             </a:r>
           </a:p>
           <a:p xmlns:a="http://schemas.openxmlformats.org/drawingml/2006/main">
             <a:pPr algn="l">
+              <a:buNone/>
               <a:defRPr sz="1725" b="0">
                 <a:solidFill>
                   <a:srgbClr val="000000"/>
@@ -5416,7 +5482,7 @@
                 <a:ea typeface="Arial"/>
                 <a:cs typeface="Arial"/>
               </a:rPr>
-              <a:t>Snapshots + ADRs</a:t>
+              <a:t>Explicit conversions</a:t>
             </a:r>
           </a:p>
         </p:txBody>
@@ -5454,6 +5520,7 @@
           <a:lstStyle xmlns:a="http://schemas.openxmlformats.org/drawingml/2006/main"/>
           <a:p xmlns:a="http://schemas.openxmlformats.org/drawingml/2006/main">
             <a:pPr algn="l">
+              <a:buNone/>
               <a:defRPr sz="2025" b="1">
                 <a:solidFill>
                   <a:srgbClr val="000000"/>
@@ -5472,7 +5539,7 @@
                 <a:ea typeface="Arial"/>
                 <a:cs typeface="Arial"/>
               </a:rPr>
-              <a:t>Playback core</a:t>
+              <a:t>Playback authority</a:t>
             </a:r>
           </a:p>
         </p:txBody>
@@ -5510,6 +5577,7 @@
           <a:lstStyle xmlns:a="http://schemas.openxmlformats.org/drawingml/2006/main"/>
           <a:p xmlns:a="http://schemas.openxmlformats.org/drawingml/2006/main">
             <a:pPr algn="l">
+              <a:buNone/>
               <a:defRPr sz="1725" b="0">
                 <a:solidFill>
                   <a:srgbClr val="000000"/>
@@ -5528,11 +5596,12 @@
                 <a:ea typeface="Arial"/>
                 <a:cs typeface="Arial"/>
               </a:rPr>
-              <a:t>Resolver</a:t>
+              <a:t>ADR-002 review</a:t>
             </a:r>
           </a:p>
           <a:p xmlns:a="http://schemas.openxmlformats.org/drawingml/2006/main">
             <a:pPr algn="l">
+              <a:buNone/>
               <a:defRPr sz="1725" b="0">
                 <a:solidFill>
                   <a:srgbClr val="000000"/>
@@ -5551,11 +5620,12 @@
                 <a:ea typeface="Arial"/>
                 <a:cs typeface="Arial"/>
               </a:rPr>
-              <a:t>State machine</a:t>
+              <a:t>Session state machine</a:t>
             </a:r>
           </a:p>
           <a:p xmlns:a="http://schemas.openxmlformats.org/drawingml/2006/main">
             <a:pPr algn="l">
+              <a:buNone/>
               <a:defRPr sz="1725" b="0">
                 <a:solidFill>
                   <a:srgbClr val="000000"/>
@@ -5574,7 +5644,7 @@
                 <a:ea typeface="Arial"/>
                 <a:cs typeface="Arial"/>
               </a:rPr>
-              <a:t>Master clock</a:t>
+              <a:t>Immutable status</a:t>
             </a:r>
           </a:p>
         </p:txBody>
@@ -5612,6 +5682,7 @@
           <a:lstStyle xmlns:a="http://schemas.openxmlformats.org/drawingml/2006/main"/>
           <a:p xmlns:a="http://schemas.openxmlformats.org/drawingml/2006/main">
             <a:pPr algn="l">
+              <a:buNone/>
               <a:defRPr sz="2025" b="1">
                 <a:solidFill>
                   <a:srgbClr val="000000"/>
@@ -5668,6 +5739,7 @@
           <a:lstStyle xmlns:a="http://schemas.openxmlformats.org/drawingml/2006/main"/>
           <a:p xmlns:a="http://schemas.openxmlformats.org/drawingml/2006/main">
             <a:pPr algn="l">
+              <a:buNone/>
               <a:defRPr sz="1725" b="0">
                 <a:solidFill>
                   <a:srgbClr val="000000"/>
@@ -5691,6 +5763,7 @@
           </a:p>
           <a:p xmlns:a="http://schemas.openxmlformats.org/drawingml/2006/main">
             <a:pPr algn="l">
+              <a:buNone/>
               <a:defRPr sz="1725" b="0">
                 <a:solidFill>
                   <a:srgbClr val="000000"/>
@@ -5714,6 +5787,7 @@
           </a:p>
           <a:p xmlns:a="http://schemas.openxmlformats.org/drawingml/2006/main">
             <a:pPr algn="l">
+              <a:buNone/>
               <a:defRPr sz="1725" b="0">
                 <a:solidFill>
                   <a:srgbClr val="000000"/>

</xml_diff>

<commit_message>
Propose ADR-003 immutable playback snapshots
</commit_message>
<xml_diff>
--- a/MiniEditorCoexistence/docs/Timeline-Playback-Engine-Learning.pptx
+++ b/MiniEditorCoexistence/docs/Timeline-Playback-Engine-Learning.pptx
@@ -2,18 +2,19 @@
 <file path=ppt/presentation.xml><?xml version="1.0" encoding="utf-8"?>
 <p:presentation xmlns:p="http://schemas.openxmlformats.org/presentationml/2006/main">
   <p:sldMasterIdLst>
-    <p:sldMasterId xmlns:r="http://schemas.openxmlformats.org/officeDocument/2006/relationships" id="2147483648" r:id="Raac93b11c8a84f4e"/>
+    <p:sldMasterId xmlns:r="http://schemas.openxmlformats.org/officeDocument/2006/relationships" id="2147483648" r:id="Rb34771e0f35045d1"/>
   </p:sldMasterIdLst>
   <p:notesMasterIdLst>
-    <p:notesMasterId xmlns:r="http://schemas.openxmlformats.org/officeDocument/2006/relationships" r:id="Ra1cc336f57c14a62"/>
+    <p:notesMasterId xmlns:r="http://schemas.openxmlformats.org/officeDocument/2006/relationships" r:id="Rbebe91578f7a4777"/>
   </p:notesMasterIdLst>
   <p:sldIdLst>
-    <p:sldId xmlns:r="http://schemas.openxmlformats.org/officeDocument/2006/relationships" id="256" r:id="R7341411fe8ed4de9"/>
-    <p:sldId xmlns:r="http://schemas.openxmlformats.org/officeDocument/2006/relationships" id="257" r:id="Rc27900ce56e14e47"/>
-    <p:sldId xmlns:r="http://schemas.openxmlformats.org/officeDocument/2006/relationships" id="258" r:id="R4e9c0bd86816485b"/>
-    <p:sldId xmlns:r="http://schemas.openxmlformats.org/officeDocument/2006/relationships" id="259" r:id="Rf156b321451744b2"/>
-    <p:sldId xmlns:r="http://schemas.openxmlformats.org/officeDocument/2006/relationships" id="260" r:id="Rc0b258debaf34b50"/>
-    <p:sldId xmlns:r="http://schemas.openxmlformats.org/officeDocument/2006/relationships" id="261" r:id="Ra306bb9c6d7c41e2"/>
+    <p:sldId xmlns:r="http://schemas.openxmlformats.org/officeDocument/2006/relationships" id="256" r:id="Rd53465e63f3b487e"/>
+    <p:sldId xmlns:r="http://schemas.openxmlformats.org/officeDocument/2006/relationships" id="257" r:id="Re6eebb46fa334832"/>
+    <p:sldId xmlns:r="http://schemas.openxmlformats.org/officeDocument/2006/relationships" id="258" r:id="R4b861caa67994d83"/>
+    <p:sldId xmlns:r="http://schemas.openxmlformats.org/officeDocument/2006/relationships" id="259" r:id="Recd7100daf6e48ac"/>
+    <p:sldId xmlns:r="http://schemas.openxmlformats.org/officeDocument/2006/relationships" id="260" r:id="R16cfbabff0514e9c"/>
+    <p:sldId xmlns:r="http://schemas.openxmlformats.org/officeDocument/2006/relationships" id="261" r:id="R5c8eee9bdb5e4e3e"/>
+    <p:sldId xmlns:r="http://schemas.openxmlformats.org/officeDocument/2006/relationships" id="262" r:id="R244e55fd73a94551"/>
   </p:sldIdLst>
   <p:sldSz cx="12192000" cy="6858000"/>
   <p:notesSz cx="6858000" cy="9144000"/>
@@ -882,6 +883,81 @@
 </p:notes>
 </file>
 
+<file path=ppt/notesSlides/notesSlide7.xml><?xml version="1.0" encoding="utf-8"?>
+<p:notes xmlns:p="http://schemas.openxmlformats.org/presentationml/2006/main">
+  <p:cSld>
+    <p:spTree>
+      <p:nvGrpSpPr>
+        <p:cNvPr id="1" name=""/>
+        <p:cNvGrpSpPr/>
+        <p:nvPr/>
+      </p:nvGrpSpPr>
+      <p:grpSpPr>
+        <a:xfrm xmlns:a="http://schemas.openxmlformats.org/drawingml/2006/main"/>
+      </p:grpSpPr>
+      <p:sp>
+        <p:nvSpPr>
+          <p:cNvPr id="2" name="Slide Image Placeholder 1"/>
+          <p:cNvSpPr>
+            <a:spLocks xmlns:a="http://schemas.openxmlformats.org/drawingml/2006/main" noGrp="1"/>
+          </p:cNvSpPr>
+          <p:nvPr>
+            <p:ph type="sldImg" idx="0"/>
+          </p:nvPr>
+        </p:nvSpPr>
+        <p:spPr/>
+      </p:sp>
+      <p:sp>
+        <p:nvSpPr>
+          <p:cNvPr id="3" name="Notes Placeholder 2"/>
+          <p:cNvSpPr>
+            <a:spLocks xmlns:a="http://schemas.openxmlformats.org/drawingml/2006/main" noGrp="1"/>
+          </p:cNvSpPr>
+          <p:nvPr>
+            <p:ph type="body" idx="1"/>
+          </p:nvPr>
+        </p:nvSpPr>
+        <p:spPr/>
+        <p:txBody>
+          <a:bodyPr xmlns:a="http://schemas.openxmlformats.org/drawingml/2006/main"/>
+          <a:lstStyle xmlns:a="http://schemas.openxmlformats.org/drawingml/2006/main"/>
+          <a:p xmlns:a="http://schemas.openxmlformats.org/drawingml/2006/main">
+            <a:r>
+              <a:t>[Sources]</a:t>
+            </a:r>
+          </a:p>
+          <a:p xmlns:a="http://schemas.openxmlformats.org/drawingml/2006/main">
+            <a:r>
+              <a:t>- D:/Qt/Samples/MiniEditorCoexistence/docs/architecture/current-playback-architecture.md</a:t>
+            </a:r>
+          </a:p>
+        </p:txBody>
+      </p:sp>
+      <p:sp>
+        <p:nvSpPr>
+          <p:cNvPr id="4" name="Slide Number Placeholder 3"/>
+          <p:cNvSpPr>
+            <a:spLocks xmlns:a="http://schemas.openxmlformats.org/drawingml/2006/main" noGrp="1"/>
+          </p:cNvSpPr>
+          <p:nvPr>
+            <p:ph type="sldNum" idx="5"/>
+          </p:nvPr>
+        </p:nvSpPr>
+        <p:spPr/>
+        <p:txBody>
+          <a:bodyPr xmlns:a="http://schemas.openxmlformats.org/drawingml/2006/main"/>
+          <a:lstStyle xmlns:a="http://schemas.openxmlformats.org/drawingml/2006/main"/>
+          <a:p xmlns:a="http://schemas.openxmlformats.org/drawingml/2006/main"/>
+        </p:txBody>
+      </p:sp>
+    </p:spTree>
+  </p:cSld>
+  <p:clrMapOvr>
+    <a:masterClrMapping xmlns:a="http://schemas.openxmlformats.org/drawingml/2006/main"/>
+  </p:clrMapOvr>
+</p:notes>
+</file>
+
 <file path=ppt/slideLayouts/slideLayout1.xml><?xml version="1.0" encoding="utf-8"?>
 <p:sldLayout xmlns:p="http://schemas.openxmlformats.org/presentationml/2006/main" type="title">
   <p:cSld name="Title Slide">
@@ -920,7 +996,7 @@
   </p:cSld>
   <p:clrMap bg1="lt1" tx1="dk1" bg2="lt2" tx2="dk2" accent1="accent1" accent2="accent2" accent3="accent3" accent4="accent4" accent5="accent5" accent6="accent6" hlink="hlink" folHlink="folHlink"/>
   <p:sldLayoutIdLst>
-    <p:sldLayoutId xmlns:r="http://schemas.openxmlformats.org/officeDocument/2006/relationships" id="2147483649" r:id="Rb616a9820bdd4b60"/>
+    <p:sldLayoutId xmlns:r="http://schemas.openxmlformats.org/officeDocument/2006/relationships" id="2147483649" r:id="R553269e2d28e49e8"/>
   </p:sldLayoutIdLst>
   <p:txStyles>
     <p:titleStyle>
@@ -1713,7 +1789,7 @@
                 <a:ea typeface="Arial"/>
                 <a:cs typeface="Arial"/>
               </a:rPr>
-              <a:t>ADR-001 accepted · strong media time domains</a:t>
+              <a:t>ADR-001 + ADR-002 accepted · ADR-003 proposed</a:t>
             </a:r>
           </a:p>
         </p:txBody>
@@ -3395,7 +3471,7 @@
                 <a:ea typeface="Arial"/>
                 <a:cs typeface="Arial"/>
               </a:rPr>
-              <a:t>One playback session will become the authority</a:t>
+              <a:t>One playback session is the authority</a:t>
             </a:r>
           </a:p>
         </p:txBody>
@@ -4215,7 +4291,7 @@
                 <a:ea typeface="Arial"/>
                 <a:cs typeface="Arial"/>
               </a:rPr>
-              <a:t>UI focus requests playback; it no longer defines playback identity.</a:t>
+              <a:t>UI focus may request playback; it never defines transport identity.</a:t>
             </a:r>
           </a:p>
         </p:txBody>
@@ -5263,7 +5339,7 @@
                 <a:ea typeface="Arial"/>
                 <a:cs typeface="Arial"/>
               </a:rPr>
-              <a:t>NEXT</a:t>
+              <a:t>ACCEPTED</a:t>
             </a:r>
           </a:p>
         </p:txBody>
@@ -5320,7 +5396,7 @@
                 <a:ea typeface="Arial"/>
                 <a:cs typeface="Arial"/>
               </a:rPr>
-              <a:t>MILESTONE</a:t>
+              <a:t>PROPOSED</a:t>
             </a:r>
           </a:p>
         </p:txBody>
@@ -5596,7 +5672,7 @@
                 <a:ea typeface="Arial"/>
                 <a:cs typeface="Arial"/>
               </a:rPr>
-              <a:t>ADR-002 review</a:t>
+              <a:t>ADR-002 accepted</a:t>
             </a:r>
           </a:p>
           <a:p xmlns:a="http://schemas.openxmlformats.org/drawingml/2006/main">
@@ -5620,7 +5696,7 @@
                 <a:ea typeface="Arial"/>
                 <a:cs typeface="Arial"/>
               </a:rPr>
-              <a:t>Session state machine</a:t>
+              <a:t>Single transport authority</a:t>
             </a:r>
           </a:p>
           <a:p xmlns:a="http://schemas.openxmlformats.org/drawingml/2006/main">
@@ -5644,7 +5720,7 @@
                 <a:ea typeface="Arial"/>
                 <a:cs typeface="Arial"/>
               </a:rPr>
-              <a:t>Immutable status</a:t>
+              <a:t>Async commands + status</a:t>
             </a:r>
           </a:p>
         </p:txBody>
@@ -5701,7 +5777,7 @@
                 <a:ea typeface="Arial"/>
                 <a:cs typeface="Arial"/>
               </a:rPr>
-              <a:t>Media pipeline</a:t>
+              <a:t>Snapshots + frames</a:t>
             </a:r>
           </a:p>
         </p:txBody>
@@ -5758,7 +5834,7 @@
                 <a:ea typeface="Arial"/>
                 <a:cs typeface="Arial"/>
               </a:rPr>
-              <a:t>Async decode</a:t>
+              <a:t>ADR-003 proposed</a:t>
             </a:r>
           </a:p>
           <a:p xmlns:a="http://schemas.openxmlformats.org/drawingml/2006/main">
@@ -5782,7 +5858,7 @@
                 <a:ea typeface="Arial"/>
                 <a:cs typeface="Arial"/>
               </a:rPr>
-              <a:t>Frame queues</a:t>
+              <a:t>Immutable snapshots</a:t>
             </a:r>
           </a:p>
           <a:p xmlns:a="http://schemas.openxmlformats.org/drawingml/2006/main">
@@ -5806,7 +5882,7 @@
                 <a:ea typeface="Arial"/>
                 <a:cs typeface="Arial"/>
               </a:rPr>
-              <a:t>Composition + UI integration</a:t>
+              <a:t>Generation-gated frames</a:t>
             </a:r>
           </a:p>
         </p:txBody>
@@ -5815,6 +5891,636 @@
     <p:extLst>
       <p:ext uri="{BB962C8B-B14F-4D97-AF65-F5344CB8AC3E}">
         <p14:creationId xmlns:p14="http://schemas.microsoft.com/office/powerpoint/2010/main" val="2074673795"/>
+      </p:ext>
+    </p:extLst>
+  </p:cSld>
+</p:sld>
+</file>
+
+<file path=ppt/slides/slide7.xml><?xml version="1.0" encoding="utf-8"?>
+<p:sld xmlns:p="http://schemas.openxmlformats.org/presentationml/2006/main">
+  <p:cSld>
+    <p:bg>
+      <p:bgPr>
+        <a:solidFill xmlns:a="http://schemas.openxmlformats.org/drawingml/2006/main">
+          <a:srgbClr val="FFFFFF"/>
+        </a:solidFill>
+      </p:bgPr>
+    </p:bg>
+    <p:spTree>
+      <p:nvGrpSpPr>
+        <p:cNvPr id="1" name=""/>
+        <p:cNvGrpSpPr/>
+        <p:nvPr/>
+      </p:nvGrpSpPr>
+      <p:grpSpPr>
+        <a:xfrm xmlns:a="http://schemas.openxmlformats.org/drawingml/2006/main"/>
+      </p:grpSpPr>
+      <p:sp>
+        <p:nvSpPr>
+          <p:cNvPr id="12" name="slide-5-title">
+            <a:extLst xmlns:a="http://schemas.openxmlformats.org/drawingml/2006/main">
+              <a:ext uri="{FF2B5EF4-FFF2-40B4-BE49-F238E27FC236}">
+                <a16:creationId xmlns:a16="http://schemas.microsoft.com/office/drawing/2014/main" id="{5A14D27E-0B2E-4A67-9733-B580C7628E19}"/>
+              </a:ext>
+            </a:extLst>
+          </p:cNvPr>
+          <p:cNvSpPr>
+            <a:spLocks xmlns:a="http://schemas.openxmlformats.org/drawingml/2006/main" noGrp="1"/>
+          </p:cNvSpPr>
+          <p:nvPr/>
+        </p:nvSpPr>
+        <p:spPr>
+          <a:xfrm xmlns:a="http://schemas.openxmlformats.org/drawingml/2006/main">
+            <a:off x="400050" y="323850"/>
+            <a:ext cx="11001375" cy="742950"/>
+          </a:xfrm>
+          <a:prstGeom xmlns:a="http://schemas.openxmlformats.org/drawingml/2006/main" prst="rect">
+            <a:avLst/>
+          </a:prstGeom>
+          <a:noFill xmlns:a="http://schemas.openxmlformats.org/drawingml/2006/main"/>
+          <a:ln xmlns:a="http://schemas.openxmlformats.org/drawingml/2006/main" w="0">
+            <a:noFill/>
+            <a:prstDash val="solid"/>
+          </a:ln>
+        </p:spPr>
+        <p:txBody>
+          <a:bodyPr xmlns:a="http://schemas.openxmlformats.org/drawingml/2006/main" anchor="t"/>
+          <a:lstStyle xmlns:a="http://schemas.openxmlformats.org/drawingml/2006/main"/>
+          <a:p xmlns:a="http://schemas.openxmlformats.org/drawingml/2006/main">
+            <a:pPr algn="l">
+              <a:buNone/>
+              <a:defRPr sz="3150" b="1">
+                <a:solidFill>
+                  <a:srgbClr val="000000"/>
+                </a:solidFill>
+                <a:latin typeface="Arial"/>
+                <a:ea typeface="Arial"/>
+                <a:cs typeface="Arial"/>
+              </a:defRPr>
+            </a:pPr>
+            <a:r>
+              <a:rPr sz="3150" b="1">
+                <a:solidFill>
+                  <a:srgbClr val="000000"/>
+                </a:solidFill>
+                <a:latin typeface="Arial"/>
+                <a:ea typeface="Arial"/>
+                <a:cs typeface="Arial"/>
+              </a:rPr>
+              <a:t>Three identities reject three kinds of stale work</a:t>
+            </a:r>
+          </a:p>
+        </p:txBody>
+      </p:sp>
+      <p:sp>
+        <p:nvSpPr>
+          <p:cNvPr id="2" name="">
+            <a:extLst xmlns:a="http://schemas.openxmlformats.org/drawingml/2006/main">
+              <a:ext uri="{FF2B5EF4-FFF2-40B4-BE49-F238E27FC236}">
+                <a16:creationId xmlns:a16="http://schemas.microsoft.com/office/drawing/2014/main" id="{D090A24A-AC53-4984-80FE-4C80614725A5}"/>
+              </a:ext>
+            </a:extLst>
+          </p:cNvPr>
+          <p:cNvSpPr>
+            <a:spLocks xmlns:a="http://schemas.openxmlformats.org/drawingml/2006/main" noGrp="1"/>
+          </p:cNvSpPr>
+          <p:nvPr/>
+        </p:nvSpPr>
+        <p:spPr>
+          <a:xfrm xmlns:a="http://schemas.openxmlformats.org/drawingml/2006/main">
+            <a:off x="400050" y="1181100"/>
+            <a:ext cx="11391900" cy="0"/>
+          </a:xfrm>
+          <a:prstGeom xmlns:a="http://schemas.openxmlformats.org/drawingml/2006/main" prst="line">
+            <a:avLst/>
+          </a:prstGeom>
+          <a:noFill xmlns:a="http://schemas.openxmlformats.org/drawingml/2006/main"/>
+          <a:ln xmlns:a="http://schemas.openxmlformats.org/drawingml/2006/main" w="9525">
+            <a:solidFill>
+              <a:srgbClr val="000000"/>
+            </a:solidFill>
+            <a:prstDash val="solid"/>
+          </a:ln>
+        </p:spPr>
+      </p:sp>
+      <p:sp>
+        <p:nvSpPr>
+          <p:cNvPr id="3" name="slide-5-number">
+            <a:extLst xmlns:a="http://schemas.openxmlformats.org/drawingml/2006/main">
+              <a:ext uri="{FF2B5EF4-FFF2-40B4-BE49-F238E27FC236}">
+                <a16:creationId xmlns:a16="http://schemas.microsoft.com/office/drawing/2014/main" id="{F1E9F118-7AB7-4B30-BB8D-B522EB43F21B}"/>
+              </a:ext>
+            </a:extLst>
+          </p:cNvPr>
+          <p:cNvSpPr>
+            <a:spLocks xmlns:a="http://schemas.openxmlformats.org/drawingml/2006/main" noGrp="1"/>
+          </p:cNvSpPr>
+          <p:nvPr/>
+        </p:nvSpPr>
+        <p:spPr>
+          <a:xfrm xmlns:a="http://schemas.openxmlformats.org/drawingml/2006/main">
+            <a:off x="11334750" y="6334125"/>
+            <a:ext cx="457200" cy="209550"/>
+          </a:xfrm>
+          <a:prstGeom xmlns:a="http://schemas.openxmlformats.org/drawingml/2006/main" prst="rect">
+            <a:avLst/>
+          </a:prstGeom>
+          <a:noFill xmlns:a="http://schemas.openxmlformats.org/drawingml/2006/main"/>
+          <a:ln xmlns:a="http://schemas.openxmlformats.org/drawingml/2006/main" w="0">
+            <a:noFill/>
+            <a:prstDash val="solid"/>
+          </a:ln>
+        </p:spPr>
+        <p:txBody>
+          <a:bodyPr xmlns:a="http://schemas.openxmlformats.org/drawingml/2006/main" anchor="t"/>
+          <a:lstStyle xmlns:a="http://schemas.openxmlformats.org/drawingml/2006/main"/>
+          <a:p xmlns:a="http://schemas.openxmlformats.org/drawingml/2006/main">
+            <a:pPr algn="r">
+              <a:buNone/>
+              <a:defRPr sz="1200" b="0">
+                <a:solidFill>
+                  <a:srgbClr val="62666D"/>
+                </a:solidFill>
+                <a:latin typeface="Arial"/>
+                <a:ea typeface="Arial"/>
+                <a:cs typeface="Arial"/>
+              </a:defRPr>
+            </a:pPr>
+            <a:r>
+              <a:rPr sz="1200" b="0">
+                <a:solidFill>
+                  <a:srgbClr val="62666D"/>
+                </a:solidFill>
+                <a:latin typeface="Arial"/>
+                <a:ea typeface="Arial"/>
+                <a:cs typeface="Arial"/>
+              </a:rPr>
+              <a:t>7</a:t>
+            </a:r>
+          </a:p>
+        </p:txBody>
+      </p:sp>
+      <p:sp>
+        <p:nvSpPr>
+          <p:cNvPr id="4" name="lens-ownership-title">
+            <a:extLst xmlns:a="http://schemas.openxmlformats.org/drawingml/2006/main">
+              <a:ext uri="{FF2B5EF4-FFF2-40B4-BE49-F238E27FC236}">
+                <a16:creationId xmlns:a16="http://schemas.microsoft.com/office/drawing/2014/main" id="{E861B54C-D306-418C-BD7B-F64ABEFEB7A5}"/>
+              </a:ext>
+            </a:extLst>
+          </p:cNvPr>
+          <p:cNvSpPr>
+            <a:spLocks xmlns:a="http://schemas.openxmlformats.org/drawingml/2006/main" noGrp="1"/>
+          </p:cNvSpPr>
+          <p:nvPr/>
+        </p:nvSpPr>
+        <p:spPr>
+          <a:xfrm xmlns:a="http://schemas.openxmlformats.org/drawingml/2006/main">
+            <a:off x="476250" y="1885950"/>
+            <a:ext cx="4762500" cy="381000"/>
+          </a:xfrm>
+          <a:prstGeom xmlns:a="http://schemas.openxmlformats.org/drawingml/2006/main" prst="rect">
+            <a:avLst/>
+          </a:prstGeom>
+          <a:noFill xmlns:a="http://schemas.openxmlformats.org/drawingml/2006/main"/>
+          <a:ln xmlns:a="http://schemas.openxmlformats.org/drawingml/2006/main" w="0">
+            <a:noFill/>
+            <a:prstDash val="solid"/>
+          </a:ln>
+        </p:spPr>
+        <p:txBody>
+          <a:bodyPr xmlns:a="http://schemas.openxmlformats.org/drawingml/2006/main" anchor="t"/>
+          <a:lstStyle xmlns:a="http://schemas.openxmlformats.org/drawingml/2006/main"/>
+          <a:p xmlns:a="http://schemas.openxmlformats.org/drawingml/2006/main">
+            <a:pPr algn="l">
+              <a:buNone/>
+              <a:defRPr sz="1875" b="1">
+                <a:solidFill>
+                  <a:srgbClr val="3D8DFF"/>
+                </a:solidFill>
+                <a:latin typeface="Arial"/>
+                <a:ea typeface="Arial"/>
+                <a:cs typeface="Arial"/>
+              </a:defRPr>
+            </a:pPr>
+            <a:r>
+              <a:rPr sz="1875" b="1">
+                <a:solidFill>
+                  <a:srgbClr val="3D8DFF"/>
+                </a:solidFill>
+                <a:latin typeface="Arial"/>
+                <a:ea typeface="Arial"/>
+                <a:cs typeface="Arial"/>
+              </a:rPr>
+              <a:t>SNAPSHOT REVISION</a:t>
+            </a:r>
+          </a:p>
+        </p:txBody>
+      </p:sp>
+      <p:sp>
+        <p:nvSpPr>
+          <p:cNvPr id="5" name="lens-ownership-body">
+            <a:extLst xmlns:a="http://schemas.openxmlformats.org/drawingml/2006/main">
+              <a:ext uri="{FF2B5EF4-FFF2-40B4-BE49-F238E27FC236}">
+                <a16:creationId xmlns:a16="http://schemas.microsoft.com/office/drawing/2014/main" id="{4F17BE9A-1B9C-4A50-A208-5FC4FEBBCC9A}"/>
+              </a:ext>
+            </a:extLst>
+          </p:cNvPr>
+          <p:cNvSpPr>
+            <a:spLocks xmlns:a="http://schemas.openxmlformats.org/drawingml/2006/main" noGrp="1"/>
+          </p:cNvSpPr>
+          <p:nvPr/>
+        </p:nvSpPr>
+        <p:spPr>
+          <a:xfrm xmlns:a="http://schemas.openxmlformats.org/drawingml/2006/main">
+            <a:off x="476250" y="2381250"/>
+            <a:ext cx="4762500" cy="800100"/>
+          </a:xfrm>
+          <a:prstGeom xmlns:a="http://schemas.openxmlformats.org/drawingml/2006/main" prst="rect">
+            <a:avLst/>
+          </a:prstGeom>
+          <a:noFill xmlns:a="http://schemas.openxmlformats.org/drawingml/2006/main"/>
+          <a:ln xmlns:a="http://schemas.openxmlformats.org/drawingml/2006/main" w="0">
+            <a:noFill/>
+            <a:prstDash val="solid"/>
+          </a:ln>
+        </p:spPr>
+        <p:txBody>
+          <a:bodyPr xmlns:a="http://schemas.openxmlformats.org/drawingml/2006/main" anchor="t"/>
+          <a:lstStyle xmlns:a="http://schemas.openxmlformats.org/drawingml/2006/main"/>
+          <a:p xmlns:a="http://schemas.openxmlformats.org/drawingml/2006/main">
+            <a:pPr algn="l">
+              <a:buNone/>
+              <a:defRPr sz="1875" b="0">
+                <a:solidFill>
+                  <a:srgbClr val="000000"/>
+                </a:solidFill>
+                <a:latin typeface="Arial"/>
+                <a:ea typeface="Arial"/>
+                <a:cs typeface="Arial"/>
+              </a:defRPr>
+            </a:pPr>
+            <a:r>
+              <a:rPr sz="1875" b="0">
+                <a:solidFill>
+                  <a:srgbClr val="000000"/>
+                </a:solidFill>
+                <a:latin typeface="Arial"/>
+                <a:ea typeface="Arial"/>
+                <a:cs typeface="Arial"/>
+              </a:rPr>
+              <a:t>Which committed editor state does playback read?</a:t>
+            </a:r>
+          </a:p>
+        </p:txBody>
+      </p:sp>
+      <p:sp>
+        <p:nvSpPr>
+          <p:cNvPr id="6" name="lens-authority-title">
+            <a:extLst xmlns:a="http://schemas.openxmlformats.org/drawingml/2006/main">
+              <a:ext uri="{FF2B5EF4-FFF2-40B4-BE49-F238E27FC236}">
+                <a16:creationId xmlns:a16="http://schemas.microsoft.com/office/drawing/2014/main" id="{D7C4E810-0056-4796-B563-DF37CAA2262B}"/>
+              </a:ext>
+            </a:extLst>
+          </p:cNvPr>
+          <p:cNvSpPr>
+            <a:spLocks xmlns:a="http://schemas.openxmlformats.org/drawingml/2006/main" noGrp="1"/>
+          </p:cNvSpPr>
+          <p:nvPr/>
+        </p:nvSpPr>
+        <p:spPr>
+          <a:xfrm xmlns:a="http://schemas.openxmlformats.org/drawingml/2006/main">
+            <a:off x="6286500" y="1885950"/>
+            <a:ext cx="4762500" cy="381000"/>
+          </a:xfrm>
+          <a:prstGeom xmlns:a="http://schemas.openxmlformats.org/drawingml/2006/main" prst="rect">
+            <a:avLst/>
+          </a:prstGeom>
+          <a:noFill xmlns:a="http://schemas.openxmlformats.org/drawingml/2006/main"/>
+          <a:ln xmlns:a="http://schemas.openxmlformats.org/drawingml/2006/main" w="0">
+            <a:noFill/>
+            <a:prstDash val="solid"/>
+          </a:ln>
+        </p:spPr>
+        <p:txBody>
+          <a:bodyPr xmlns:a="http://schemas.openxmlformats.org/drawingml/2006/main" anchor="t"/>
+          <a:lstStyle xmlns:a="http://schemas.openxmlformats.org/drawingml/2006/main"/>
+          <a:p xmlns:a="http://schemas.openxmlformats.org/drawingml/2006/main">
+            <a:pPr algn="l">
+              <a:buNone/>
+              <a:defRPr sz="1875" b="1">
+                <a:solidFill>
+                  <a:srgbClr val="3D8DFF"/>
+                </a:solidFill>
+                <a:latin typeface="Arial"/>
+                <a:ea typeface="Arial"/>
+                <a:cs typeface="Arial"/>
+              </a:defRPr>
+            </a:pPr>
+            <a:r>
+              <a:rPr sz="1875" b="1">
+                <a:solidFill>
+                  <a:srgbClr val="3D8DFF"/>
+                </a:solidFill>
+                <a:latin typeface="Arial"/>
+                <a:ea typeface="Arial"/>
+                <a:cs typeface="Arial"/>
+              </a:rPr>
+              <a:t>PLAYBACK GENERATION</a:t>
+            </a:r>
+          </a:p>
+        </p:txBody>
+      </p:sp>
+      <p:sp>
+        <p:nvSpPr>
+          <p:cNvPr id="7" name="lens-authority-body">
+            <a:extLst xmlns:a="http://schemas.openxmlformats.org/drawingml/2006/main">
+              <a:ext uri="{FF2B5EF4-FFF2-40B4-BE49-F238E27FC236}">
+                <a16:creationId xmlns:a16="http://schemas.microsoft.com/office/drawing/2014/main" id="{6EDD8EC1-0AD6-4651-BA84-6F101BE30752}"/>
+              </a:ext>
+            </a:extLst>
+          </p:cNvPr>
+          <p:cNvSpPr>
+            <a:spLocks xmlns:a="http://schemas.openxmlformats.org/drawingml/2006/main" noGrp="1"/>
+          </p:cNvSpPr>
+          <p:nvPr/>
+        </p:nvSpPr>
+        <p:spPr>
+          <a:xfrm xmlns:a="http://schemas.openxmlformats.org/drawingml/2006/main">
+            <a:off x="6286500" y="2381250"/>
+            <a:ext cx="4762500" cy="800100"/>
+          </a:xfrm>
+          <a:prstGeom xmlns:a="http://schemas.openxmlformats.org/drawingml/2006/main" prst="rect">
+            <a:avLst/>
+          </a:prstGeom>
+          <a:noFill xmlns:a="http://schemas.openxmlformats.org/drawingml/2006/main"/>
+          <a:ln xmlns:a="http://schemas.openxmlformats.org/drawingml/2006/main" w="0">
+            <a:noFill/>
+            <a:prstDash val="solid"/>
+          </a:ln>
+        </p:spPr>
+        <p:txBody>
+          <a:bodyPr xmlns:a="http://schemas.openxmlformats.org/drawingml/2006/main" anchor="t"/>
+          <a:lstStyle xmlns:a="http://schemas.openxmlformats.org/drawingml/2006/main"/>
+          <a:p xmlns:a="http://schemas.openxmlformats.org/drawingml/2006/main">
+            <a:pPr algn="l">
+              <a:buNone/>
+              <a:defRPr sz="1875" b="0">
+                <a:solidFill>
+                  <a:srgbClr val="000000"/>
+                </a:solidFill>
+                <a:latin typeface="Arial"/>
+                <a:ea typeface="Arial"/>
+                <a:cs typeface="Arial"/>
+              </a:defRPr>
+            </a:pPr>
+            <a:r>
+              <a:rPr sz="1875" b="0">
+                <a:solidFill>
+                  <a:srgbClr val="000000"/>
+                </a:solidFill>
+                <a:latin typeface="Arial"/>
+                <a:ea typeface="Arial"/>
+                <a:cs typeface="Arial"/>
+              </a:rPr>
+              <a:t>Which transport epoch may affect playback?</a:t>
+            </a:r>
+          </a:p>
+        </p:txBody>
+      </p:sp>
+      <p:sp>
+        <p:nvSpPr>
+          <p:cNvPr id="8" name="lens-thread-title">
+            <a:extLst xmlns:a="http://schemas.openxmlformats.org/drawingml/2006/main">
+              <a:ext uri="{FF2B5EF4-FFF2-40B4-BE49-F238E27FC236}">
+                <a16:creationId xmlns:a16="http://schemas.microsoft.com/office/drawing/2014/main" id="{E76A7AFC-A12A-4F4D-B584-52319093A853}"/>
+              </a:ext>
+            </a:extLst>
+          </p:cNvPr>
+          <p:cNvSpPr>
+            <a:spLocks xmlns:a="http://schemas.openxmlformats.org/drawingml/2006/main" noGrp="1"/>
+          </p:cNvSpPr>
+          <p:nvPr/>
+        </p:nvSpPr>
+        <p:spPr>
+          <a:xfrm xmlns:a="http://schemas.openxmlformats.org/drawingml/2006/main">
+            <a:off x="476250" y="3905250"/>
+            <a:ext cx="4762500" cy="381000"/>
+          </a:xfrm>
+          <a:prstGeom xmlns:a="http://schemas.openxmlformats.org/drawingml/2006/main" prst="rect">
+            <a:avLst/>
+          </a:prstGeom>
+          <a:noFill xmlns:a="http://schemas.openxmlformats.org/drawingml/2006/main"/>
+          <a:ln xmlns:a="http://schemas.openxmlformats.org/drawingml/2006/main" w="0">
+            <a:noFill/>
+            <a:prstDash val="solid"/>
+          </a:ln>
+        </p:spPr>
+        <p:txBody>
+          <a:bodyPr xmlns:a="http://schemas.openxmlformats.org/drawingml/2006/main" anchor="t"/>
+          <a:lstStyle xmlns:a="http://schemas.openxmlformats.org/drawingml/2006/main"/>
+          <a:p xmlns:a="http://schemas.openxmlformats.org/drawingml/2006/main">
+            <a:pPr algn="l">
+              <a:buNone/>
+              <a:defRPr sz="1875" b="1">
+                <a:solidFill>
+                  <a:srgbClr val="3D8DFF"/>
+                </a:solidFill>
+                <a:latin typeface="Arial"/>
+                <a:ea typeface="Arial"/>
+                <a:cs typeface="Arial"/>
+              </a:defRPr>
+            </a:pPr>
+            <a:r>
+              <a:rPr sz="1875" b="1">
+                <a:solidFill>
+                  <a:srgbClr val="3D8DFF"/>
+                </a:solidFill>
+                <a:latin typeface="Arial"/>
+                <a:ea typeface="Arial"/>
+                <a:cs typeface="Arial"/>
+              </a:rPr>
+              <a:t>PRESENTATION REQUEST</a:t>
+            </a:r>
+          </a:p>
+        </p:txBody>
+      </p:sp>
+      <p:sp>
+        <p:nvSpPr>
+          <p:cNvPr id="9" name="lens-thread-body">
+            <a:extLst xmlns:a="http://schemas.openxmlformats.org/drawingml/2006/main">
+              <a:ext uri="{FF2B5EF4-FFF2-40B4-BE49-F238E27FC236}">
+                <a16:creationId xmlns:a16="http://schemas.microsoft.com/office/drawing/2014/main" id="{20D295AD-7235-433D-A6DD-ED702FE90E74}"/>
+              </a:ext>
+            </a:extLst>
+          </p:cNvPr>
+          <p:cNvSpPr>
+            <a:spLocks xmlns:a="http://schemas.openxmlformats.org/drawingml/2006/main" noGrp="1"/>
+          </p:cNvSpPr>
+          <p:nvPr/>
+        </p:nvSpPr>
+        <p:spPr>
+          <a:xfrm xmlns:a="http://schemas.openxmlformats.org/drawingml/2006/main">
+            <a:off x="476250" y="4400550"/>
+            <a:ext cx="4762500" cy="800100"/>
+          </a:xfrm>
+          <a:prstGeom xmlns:a="http://schemas.openxmlformats.org/drawingml/2006/main" prst="rect">
+            <a:avLst/>
+          </a:prstGeom>
+          <a:noFill xmlns:a="http://schemas.openxmlformats.org/drawingml/2006/main"/>
+          <a:ln xmlns:a="http://schemas.openxmlformats.org/drawingml/2006/main" w="0">
+            <a:noFill/>
+            <a:prstDash val="solid"/>
+          </a:ln>
+        </p:spPr>
+        <p:txBody>
+          <a:bodyPr xmlns:a="http://schemas.openxmlformats.org/drawingml/2006/main" anchor="t"/>
+          <a:lstStyle xmlns:a="http://schemas.openxmlformats.org/drawingml/2006/main"/>
+          <a:p xmlns:a="http://schemas.openxmlformats.org/drawingml/2006/main">
+            <a:pPr algn="l">
+              <a:buNone/>
+              <a:defRPr sz="1875" b="0">
+                <a:solidFill>
+                  <a:srgbClr val="000000"/>
+                </a:solidFill>
+                <a:latin typeface="Arial"/>
+                <a:ea typeface="Arial"/>
+                <a:cs typeface="Arial"/>
+              </a:defRPr>
+            </a:pPr>
+            <a:r>
+              <a:rPr sz="1875" b="0">
+                <a:solidFill>
+                  <a:srgbClr val="000000"/>
+                </a:solidFill>
+                <a:latin typeface="Arial"/>
+                <a:ea typeface="Arial"/>
+                <a:cs typeface="Arial"/>
+              </a:rPr>
+              <a:t>Which valid frame does this viewport want now?</a:t>
+            </a:r>
+          </a:p>
+        </p:txBody>
+      </p:sp>
+      <p:sp>
+        <p:nvSpPr>
+          <p:cNvPr id="10" name="lens-stale-title">
+            <a:extLst xmlns:a="http://schemas.openxmlformats.org/drawingml/2006/main">
+              <a:ext uri="{FF2B5EF4-FFF2-40B4-BE49-F238E27FC236}">
+                <a16:creationId xmlns:a16="http://schemas.microsoft.com/office/drawing/2014/main" id="{331079D4-25D6-4ECD-87E2-4F0A203359CC}"/>
+              </a:ext>
+            </a:extLst>
+          </p:cNvPr>
+          <p:cNvSpPr>
+            <a:spLocks xmlns:a="http://schemas.openxmlformats.org/drawingml/2006/main" noGrp="1"/>
+          </p:cNvSpPr>
+          <p:nvPr/>
+        </p:nvSpPr>
+        <p:spPr>
+          <a:xfrm xmlns:a="http://schemas.openxmlformats.org/drawingml/2006/main">
+            <a:off x="6286500" y="3905250"/>
+            <a:ext cx="4762500" cy="381000"/>
+          </a:xfrm>
+          <a:prstGeom xmlns:a="http://schemas.openxmlformats.org/drawingml/2006/main" prst="rect">
+            <a:avLst/>
+          </a:prstGeom>
+          <a:noFill xmlns:a="http://schemas.openxmlformats.org/drawingml/2006/main"/>
+          <a:ln xmlns:a="http://schemas.openxmlformats.org/drawingml/2006/main" w="0">
+            <a:noFill/>
+            <a:prstDash val="solid"/>
+          </a:ln>
+        </p:spPr>
+        <p:txBody>
+          <a:bodyPr xmlns:a="http://schemas.openxmlformats.org/drawingml/2006/main" anchor="t"/>
+          <a:lstStyle xmlns:a="http://schemas.openxmlformats.org/drawingml/2006/main"/>
+          <a:p xmlns:a="http://schemas.openxmlformats.org/drawingml/2006/main">
+            <a:pPr algn="l">
+              <a:buNone/>
+              <a:defRPr sz="1875" b="1">
+                <a:solidFill>
+                  <a:srgbClr val="3D8DFF"/>
+                </a:solidFill>
+                <a:latin typeface="Arial"/>
+                <a:ea typeface="Arial"/>
+                <a:cs typeface="Arial"/>
+              </a:defRPr>
+            </a:pPr>
+            <a:r>
+              <a:rPr sz="1875" b="1">
+                <a:solidFill>
+                  <a:srgbClr val="3D8DFF"/>
+                </a:solidFill>
+                <a:latin typeface="Arial"/>
+                <a:ea typeface="Arial"/>
+                <a:cs typeface="Arial"/>
+              </a:rPr>
+              <a:t>ACCEPTANCE RULE</a:t>
+            </a:r>
+          </a:p>
+        </p:txBody>
+      </p:sp>
+      <p:sp>
+        <p:nvSpPr>
+          <p:cNvPr id="11" name="lens-stale-body">
+            <a:extLst xmlns:a="http://schemas.openxmlformats.org/drawingml/2006/main">
+              <a:ext uri="{FF2B5EF4-FFF2-40B4-BE49-F238E27FC236}">
+                <a16:creationId xmlns:a16="http://schemas.microsoft.com/office/drawing/2014/main" id="{3D5369FF-BC9C-40E4-894A-99536B50BC3B}"/>
+              </a:ext>
+            </a:extLst>
+          </p:cNvPr>
+          <p:cNvSpPr>
+            <a:spLocks xmlns:a="http://schemas.openxmlformats.org/drawingml/2006/main" noGrp="1"/>
+          </p:cNvSpPr>
+          <p:nvPr/>
+        </p:nvSpPr>
+        <p:spPr>
+          <a:xfrm xmlns:a="http://schemas.openxmlformats.org/drawingml/2006/main">
+            <a:off x="6286500" y="4400550"/>
+            <a:ext cx="4762500" cy="800100"/>
+          </a:xfrm>
+          <a:prstGeom xmlns:a="http://schemas.openxmlformats.org/drawingml/2006/main" prst="rect">
+            <a:avLst/>
+          </a:prstGeom>
+          <a:noFill xmlns:a="http://schemas.openxmlformats.org/drawingml/2006/main"/>
+          <a:ln xmlns:a="http://schemas.openxmlformats.org/drawingml/2006/main" w="0">
+            <a:noFill/>
+            <a:prstDash val="solid"/>
+          </a:ln>
+        </p:spPr>
+        <p:txBody>
+          <a:bodyPr xmlns:a="http://schemas.openxmlformats.org/drawingml/2006/main" anchor="t"/>
+          <a:lstStyle xmlns:a="http://schemas.openxmlformats.org/drawingml/2006/main"/>
+          <a:p xmlns:a="http://schemas.openxmlformats.org/drawingml/2006/main">
+            <a:pPr algn="l">
+              <a:buNone/>
+              <a:defRPr sz="1875" b="0">
+                <a:solidFill>
+                  <a:srgbClr val="000000"/>
+                </a:solidFill>
+                <a:latin typeface="Arial"/>
+                <a:ea typeface="Arial"/>
+                <a:cs typeface="Arial"/>
+              </a:defRPr>
+            </a:pPr>
+            <a:r>
+              <a:rPr sz="1875" b="0">
+                <a:solidFill>
+                  <a:srgbClr val="000000"/>
+                </a:solidFill>
+                <a:latin typeface="Arial"/>
+                <a:ea typeface="Arial"/>
+                <a:cs typeface="Arial"/>
+              </a:rPr>
+              <a:t>All relevant identities must still match.</a:t>
+            </a:r>
+          </a:p>
+        </p:txBody>
+      </p:sp>
+    </p:spTree>
+    <p:extLst>
+      <p:ext uri="{BB962C8B-B14F-4D97-AF65-F5344CB8AC3E}">
+        <p14:creationId xmlns:p14="http://schemas.microsoft.com/office/powerpoint/2010/main" val="1906365049"/>
       </p:ext>
     </p:extLst>
   </p:cSld>

</xml_diff>

<commit_message>
Update learning deck for ADR-005
</commit_message>
<xml_diff>
--- a/MiniEditorCoexistence/docs/Timeline-Playback-Engine-Learning.pptx
+++ b/MiniEditorCoexistence/docs/Timeline-Playback-Engine-Learning.pptx
@@ -2,19 +2,19 @@
 <file path=ppt/presentation.xml><?xml version="1.0" encoding="utf-8"?>
 <p:presentation xmlns:p="http://schemas.openxmlformats.org/presentationml/2006/main">
   <p:sldMasterIdLst>
-    <p:sldMasterId xmlns:r="http://schemas.openxmlformats.org/officeDocument/2006/relationships" id="2147483648" r:id="Rb34771e0f35045d1"/>
+    <p:sldMasterId xmlns:r="http://schemas.openxmlformats.org/officeDocument/2006/relationships" id="2147483648" r:id="R5b76b2f293854d0c"/>
   </p:sldMasterIdLst>
   <p:notesMasterIdLst>
-    <p:notesMasterId xmlns:r="http://schemas.openxmlformats.org/officeDocument/2006/relationships" r:id="Rbebe91578f7a4777"/>
+    <p:notesMasterId xmlns:r="http://schemas.openxmlformats.org/officeDocument/2006/relationships" r:id="Rd5950517f95c4ead"/>
   </p:notesMasterIdLst>
   <p:sldIdLst>
-    <p:sldId xmlns:r="http://schemas.openxmlformats.org/officeDocument/2006/relationships" id="256" r:id="Rd53465e63f3b487e"/>
-    <p:sldId xmlns:r="http://schemas.openxmlformats.org/officeDocument/2006/relationships" id="257" r:id="Re6eebb46fa334832"/>
-    <p:sldId xmlns:r="http://schemas.openxmlformats.org/officeDocument/2006/relationships" id="258" r:id="R4b861caa67994d83"/>
-    <p:sldId xmlns:r="http://schemas.openxmlformats.org/officeDocument/2006/relationships" id="259" r:id="Recd7100daf6e48ac"/>
-    <p:sldId xmlns:r="http://schemas.openxmlformats.org/officeDocument/2006/relationships" id="260" r:id="R16cfbabff0514e9c"/>
-    <p:sldId xmlns:r="http://schemas.openxmlformats.org/officeDocument/2006/relationships" id="261" r:id="R5c8eee9bdb5e4e3e"/>
-    <p:sldId xmlns:r="http://schemas.openxmlformats.org/officeDocument/2006/relationships" id="262" r:id="R244e55fd73a94551"/>
+    <p:sldId xmlns:r="http://schemas.openxmlformats.org/officeDocument/2006/relationships" id="256" r:id="R82df10d8c5de4789"/>
+    <p:sldId xmlns:r="http://schemas.openxmlformats.org/officeDocument/2006/relationships" id="257" r:id="R33e1ef63187e4cf6"/>
+    <p:sldId xmlns:r="http://schemas.openxmlformats.org/officeDocument/2006/relationships" id="258" r:id="Rc49c7c8f28c747aa"/>
+    <p:sldId xmlns:r="http://schemas.openxmlformats.org/officeDocument/2006/relationships" id="259" r:id="Ra709e4324ec64f66"/>
+    <p:sldId xmlns:r="http://schemas.openxmlformats.org/officeDocument/2006/relationships" id="260" r:id="R13ea868d353c4e72"/>
+    <p:sldId xmlns:r="http://schemas.openxmlformats.org/officeDocument/2006/relationships" id="261" r:id="Rc77b1f6bfad74803"/>
+    <p:sldId xmlns:r="http://schemas.openxmlformats.org/officeDocument/2006/relationships" id="262" r:id="R3aae0e1bdb074c35"/>
   </p:sldIdLst>
   <p:sldSz cx="12192000" cy="6858000"/>
   <p:notesSz cx="6858000" cy="9144000"/>
@@ -996,7 +996,7 @@
   </p:cSld>
   <p:clrMap bg1="lt1" tx1="dk1" bg2="lt2" tx2="dk2" accent1="accent1" accent2="accent2" accent3="accent3" accent4="accent4" accent5="accent5" accent6="accent6" hlink="hlink" folHlink="folHlink"/>
   <p:sldLayoutIdLst>
-    <p:sldLayoutId xmlns:r="http://schemas.openxmlformats.org/officeDocument/2006/relationships" id="2147483649" r:id="R553269e2d28e49e8"/>
+    <p:sldLayoutId xmlns:r="http://schemas.openxmlformats.org/officeDocument/2006/relationships" id="2147483649" r:id="Rc931bf3de5b5445a"/>
   </p:sldLayoutIdLst>
   <p:txStyles>
     <p:titleStyle>
@@ -1789,7 +1789,7 @@
                 <a:ea typeface="Arial"/>
                 <a:cs typeface="Arial"/>
               </a:rPr>
-              <a:t>ADR-001 + ADR-002 accepted · ADR-003 proposed</a:t>
+              <a:t>ADR-001 through ADR-005 accepted · implementation next</a:t>
             </a:r>
           </a:p>
         </p:txBody>
@@ -5007,7 +5007,7 @@
                 <a:ea typeface="Arial"/>
                 <a:cs typeface="Arial"/>
               </a:rPr>
-              <a:t>The engine grows through three reviewable milestones</a:t>
+              <a:t>Five accepted contracts shape the engine</a:t>
             </a:r>
           </a:p>
         </p:txBody>
@@ -5396,7 +5396,7 @@
                 <a:ea typeface="Arial"/>
                 <a:cs typeface="Arial"/>
               </a:rPr>
-              <a:t>PROPOSED</a:t>
+              <a:t>ACCEPTED</a:t>
             </a:r>
           </a:p>
         </p:txBody>
@@ -5615,7 +5615,7 @@
                 <a:ea typeface="Arial"/>
                 <a:cs typeface="Arial"/>
               </a:rPr>
-              <a:t>Playback authority</a:t>
+              <a:t>Authority + snapshots</a:t>
             </a:r>
           </a:p>
         </p:txBody>
@@ -5672,7 +5672,7 @@
                 <a:ea typeface="Arial"/>
                 <a:cs typeface="Arial"/>
               </a:rPr>
-              <a:t>ADR-002 accepted</a:t>
+              <a:t>ADR-002 + ADR-003 accepted</a:t>
             </a:r>
           </a:p>
           <a:p xmlns:a="http://schemas.openxmlformats.org/drawingml/2006/main">
@@ -5720,7 +5720,7 @@
                 <a:ea typeface="Arial"/>
                 <a:cs typeface="Arial"/>
               </a:rPr>
-              <a:t>Async commands + status</a:t>
+              <a:t>Immutable async state</a:t>
             </a:r>
           </a:p>
         </p:txBody>
@@ -5777,7 +5777,7 @@
                 <a:ea typeface="Arial"/>
                 <a:cs typeface="Arial"/>
               </a:rPr>
-              <a:t>Snapshots + frames</a:t>
+              <a:t>Clock + thread ownership</a:t>
             </a:r>
           </a:p>
         </p:txBody>
@@ -5834,7 +5834,7 @@
                 <a:ea typeface="Arial"/>
                 <a:cs typeface="Arial"/>
               </a:rPr>
-              <a:t>ADR-003 proposed</a:t>
+              <a:t>ADR-004 + ADR-005 accepted</a:t>
             </a:r>
           </a:p>
           <a:p xmlns:a="http://schemas.openxmlformats.org/drawingml/2006/main">
@@ -5858,7 +5858,7 @@
                 <a:ea typeface="Arial"/>
                 <a:cs typeface="Arial"/>
               </a:rPr>
-              <a:t>Immutable snapshots</a:t>
+              <a:t>Master-clock policy</a:t>
             </a:r>
           </a:p>
           <a:p xmlns:a="http://schemas.openxmlformats.org/drawingml/2006/main">
@@ -5882,7 +5882,7 @@
                 <a:ea typeface="Arial"/>
                 <a:cs typeface="Arial"/>
               </a:rPr>
-              <a:t>Generation-gated frames</a:t>
+              <a:t>Explicit thread boundaries</a:t>
             </a:r>
           </a:p>
         </p:txBody>

</xml_diff>

<commit_message>
Fix roadmap slide text overlap
</commit_message>
<xml_diff>
--- a/MiniEditorCoexistence/docs/Timeline-Playback-Engine-Learning.pptx
+++ b/MiniEditorCoexistence/docs/Timeline-Playback-Engine-Learning.pptx
@@ -2,19 +2,19 @@
 <file path=ppt/presentation.xml><?xml version="1.0" encoding="utf-8"?>
 <p:presentation xmlns:p="http://schemas.openxmlformats.org/presentationml/2006/main">
   <p:sldMasterIdLst>
-    <p:sldMasterId xmlns:r="http://schemas.openxmlformats.org/officeDocument/2006/relationships" id="2147483648" r:id="R5b76b2f293854d0c"/>
+    <p:sldMasterId xmlns:r="http://schemas.openxmlformats.org/officeDocument/2006/relationships" id="2147483648" r:id="Rdb7b462c529e442a"/>
   </p:sldMasterIdLst>
   <p:notesMasterIdLst>
-    <p:notesMasterId xmlns:r="http://schemas.openxmlformats.org/officeDocument/2006/relationships" r:id="Rd5950517f95c4ead"/>
+    <p:notesMasterId xmlns:r="http://schemas.openxmlformats.org/officeDocument/2006/relationships" r:id="Rdd1c04ff052e45eb"/>
   </p:notesMasterIdLst>
   <p:sldIdLst>
-    <p:sldId xmlns:r="http://schemas.openxmlformats.org/officeDocument/2006/relationships" id="256" r:id="R82df10d8c5de4789"/>
-    <p:sldId xmlns:r="http://schemas.openxmlformats.org/officeDocument/2006/relationships" id="257" r:id="R33e1ef63187e4cf6"/>
-    <p:sldId xmlns:r="http://schemas.openxmlformats.org/officeDocument/2006/relationships" id="258" r:id="Rc49c7c8f28c747aa"/>
-    <p:sldId xmlns:r="http://schemas.openxmlformats.org/officeDocument/2006/relationships" id="259" r:id="Ra709e4324ec64f66"/>
-    <p:sldId xmlns:r="http://schemas.openxmlformats.org/officeDocument/2006/relationships" id="260" r:id="R13ea868d353c4e72"/>
-    <p:sldId xmlns:r="http://schemas.openxmlformats.org/officeDocument/2006/relationships" id="261" r:id="Rc77b1f6bfad74803"/>
-    <p:sldId xmlns:r="http://schemas.openxmlformats.org/officeDocument/2006/relationships" id="262" r:id="R3aae0e1bdb074c35"/>
+    <p:sldId xmlns:r="http://schemas.openxmlformats.org/officeDocument/2006/relationships" id="256" r:id="R3ee5ea2515a34794"/>
+    <p:sldId xmlns:r="http://schemas.openxmlformats.org/officeDocument/2006/relationships" id="257" r:id="Rfb98197509024d88"/>
+    <p:sldId xmlns:r="http://schemas.openxmlformats.org/officeDocument/2006/relationships" id="258" r:id="R14eb3db0d7e247b0"/>
+    <p:sldId xmlns:r="http://schemas.openxmlformats.org/officeDocument/2006/relationships" id="259" r:id="R9c19a87e29ef4a95"/>
+    <p:sldId xmlns:r="http://schemas.openxmlformats.org/officeDocument/2006/relationships" id="260" r:id="R1b2d3cd215c14c20"/>
+    <p:sldId xmlns:r="http://schemas.openxmlformats.org/officeDocument/2006/relationships" id="261" r:id="R74e3ca78d05348ee"/>
+    <p:sldId xmlns:r="http://schemas.openxmlformats.org/officeDocument/2006/relationships" id="262" r:id="Re65eb6d3cf8b441f"/>
   </p:sldIdLst>
   <p:sldSz cx="12192000" cy="6858000"/>
   <p:notesSz cx="6858000" cy="9144000"/>
@@ -996,7 +996,7 @@
   </p:cSld>
   <p:clrMap bg1="lt1" tx1="dk1" bg2="lt2" tx2="dk2" accent1="accent1" accent2="accent2" accent3="accent3" accent4="accent4" accent5="accent5" accent6="accent6" hlink="hlink" folHlink="folHlink"/>
   <p:sldLayoutIdLst>
-    <p:sldLayoutId xmlns:r="http://schemas.openxmlformats.org/officeDocument/2006/relationships" id="2147483649" r:id="Rc931bf3de5b5445a"/>
+    <p:sldLayoutId xmlns:r="http://schemas.openxmlformats.org/officeDocument/2006/relationships" id="2147483649" r:id="Rec09efc1aa3a45f0"/>
   </p:sldLayoutIdLst>
   <p:txStyles>
     <p:titleStyle>
@@ -5615,7 +5615,7 @@
                 <a:ea typeface="Arial"/>
                 <a:cs typeface="Arial"/>
               </a:rPr>
-              <a:t>Authority + snapshots</a:t>
+              <a:t>Authority + state</a:t>
             </a:r>
           </a:p>
         </p:txBody>
@@ -5777,7 +5777,7 @@
                 <a:ea typeface="Arial"/>
                 <a:cs typeface="Arial"/>
               </a:rPr>
-              <a:t>Clock + thread ownership</a:t>
+              <a:t>Clock + threads</a:t>
             </a:r>
           </a:p>
         </p:txBody>

</xml_diff>

<commit_message>
Update Living presentation deck to reflect all seven ADRs
Slide 1 now says ADR-001 through ADR-007 accepted; slide 6 gains a
fourth "Identity + UI" contract pillar for ADR-006/ADR-007 alongside
the existing three. Adds the markdown conversion of the deck, kept in
sync with the same content.

Co-Authored-By: Claude Sonnet 5 <noreply@anthropic.com>
</commit_message>
<xml_diff>
--- a/MiniEditorCoexistence/docs/Timeline-Playback-Engine-Learning.pptx
+++ b/MiniEditorCoexistence/docs/Timeline-Playback-Engine-Learning.pptx
@@ -1789,7 +1789,7 @@
                 <a:ea typeface="Arial"/>
                 <a:cs typeface="Arial"/>
               </a:rPr>
-              <a:t>ADR-001 through ADR-005 accepted · implementation next</a:t>
+              <a:t>ADR-001 through ADR-007 accepted · implementation next</a:t>
             </a:r>
           </a:p>
         </p:txBody>
@@ -5007,7 +5007,7 @@
                 <a:ea typeface="Arial"/>
                 <a:cs typeface="Arial"/>
               </a:rPr>
-              <a:t>Five accepted contracts shape the engine</a:t>
+              <a:t>Seven accepted contracts shape the engine</a:t>
             </a:r>
           </a:p>
         </p:txBody>
@@ -5180,7 +5180,7 @@
         </p:nvSpPr>
         <p:spPr>
           <a:xfrm xmlns:a="http://schemas.openxmlformats.org/drawingml/2006/main">
-            <a:off x="4476750" y="3124200"/>
+            <a:off x="3590925" y="3124200"/>
             <a:ext cx="190500" cy="190500"/>
           </a:xfrm>
           <a:prstGeom xmlns:a="http://schemas.openxmlformats.org/drawingml/2006/main" prst="ellipse">
@@ -5213,7 +5213,7 @@
         </p:nvSpPr>
         <p:spPr>
           <a:xfrm xmlns:a="http://schemas.openxmlformats.org/drawingml/2006/main">
-            <a:off x="8096250" y="3124200"/>
+            <a:off x="6324600" y="3124200"/>
             <a:ext cx="190500" cy="190500"/>
           </a:xfrm>
           <a:prstGeom xmlns:a="http://schemas.openxmlformats.org/drawingml/2006/main" prst="ellipse">
@@ -5303,7 +5303,7 @@
         </p:nvSpPr>
         <p:spPr>
           <a:xfrm xmlns:a="http://schemas.openxmlformats.org/drawingml/2006/main">
-            <a:off x="4476750" y="2628900"/>
+            <a:off x="3590925" y="2628900"/>
             <a:ext cx="1714500" cy="285750"/>
           </a:xfrm>
           <a:prstGeom xmlns:a="http://schemas.openxmlformats.org/drawingml/2006/main" prst="rect">
@@ -5360,8 +5360,8 @@
         </p:nvSpPr>
         <p:spPr>
           <a:xfrm xmlns:a="http://schemas.openxmlformats.org/drawingml/2006/main">
-            <a:off x="8096250" y="2628900"/>
-            <a:ext cx="2000250" cy="285750"/>
+            <a:off x="6324600" y="2628900"/>
+            <a:ext cx="1714500" cy="285750"/>
           </a:xfrm>
           <a:prstGeom xmlns:a="http://schemas.openxmlformats.org/drawingml/2006/main" prst="rect">
             <a:avLst/>
@@ -5418,7 +5418,7 @@
         <p:spPr>
           <a:xfrm xmlns:a="http://schemas.openxmlformats.org/drawingml/2006/main">
             <a:off x="857250" y="3714750"/>
-            <a:ext cx="2857500" cy="381000"/>
+            <a:ext cx="2276475" cy="381000"/>
           </a:xfrm>
           <a:prstGeom xmlns:a="http://schemas.openxmlformats.org/drawingml/2006/main" prst="rect">
             <a:avLst/>
@@ -5435,17 +5435,17 @@
           <a:p xmlns:a="http://schemas.openxmlformats.org/drawingml/2006/main">
             <a:pPr algn="l">
               <a:buNone/>
-              <a:defRPr sz="2025" b="1">
-                <a:solidFill>
-                  <a:srgbClr val="000000"/>
-                </a:solidFill>
-                <a:latin typeface="Arial"/>
-                <a:ea typeface="Arial"/>
-                <a:cs typeface="Arial"/>
-              </a:defRPr>
-            </a:pPr>
-            <a:r>
-              <a:rPr sz="2025" b="1">
+              <a:defRPr sz="1500" b="1">
+                <a:solidFill>
+                  <a:srgbClr val="000000"/>
+                </a:solidFill>
+                <a:latin typeface="Arial"/>
+                <a:ea typeface="Arial"/>
+                <a:cs typeface="Arial"/>
+              </a:defRPr>
+            </a:pPr>
+            <a:r>
+              <a:rPr sz="1500" b="1">
                 <a:solidFill>
                   <a:srgbClr val="000000"/>
                 </a:solidFill>
@@ -5475,7 +5475,7 @@
         <p:spPr>
           <a:xfrm xmlns:a="http://schemas.openxmlformats.org/drawingml/2006/main">
             <a:off x="857250" y="4210050"/>
-            <a:ext cx="2857500" cy="1143000"/>
+            <a:ext cx="2276475" cy="1400175"/>
           </a:xfrm>
           <a:prstGeom xmlns:a="http://schemas.openxmlformats.org/drawingml/2006/main" prst="rect">
             <a:avLst/>
@@ -5492,17 +5492,17 @@
           <a:p xmlns:a="http://schemas.openxmlformats.org/drawingml/2006/main">
             <a:pPr algn="l">
               <a:buNone/>
-              <a:defRPr sz="1725" b="0">
-                <a:solidFill>
-                  <a:srgbClr val="000000"/>
-                </a:solidFill>
-                <a:latin typeface="Arial"/>
-                <a:ea typeface="Arial"/>
-                <a:cs typeface="Arial"/>
-              </a:defRPr>
-            </a:pPr>
-            <a:r>
-              <a:rPr sz="1725" b="0">
+              <a:defRPr sz="1400" b="0">
+                <a:solidFill>
+                  <a:srgbClr val="000000"/>
+                </a:solidFill>
+                <a:latin typeface="Arial"/>
+                <a:ea typeface="Arial"/>
+                <a:cs typeface="Arial"/>
+              </a:defRPr>
+            </a:pPr>
+            <a:r>
+              <a:rPr sz="1400" b="0">
                 <a:solidFill>
                   <a:srgbClr val="000000"/>
                 </a:solidFill>
@@ -5516,17 +5516,17 @@
           <a:p xmlns:a="http://schemas.openxmlformats.org/drawingml/2006/main">
             <a:pPr algn="l">
               <a:buNone/>
-              <a:defRPr sz="1725" b="0">
-                <a:solidFill>
-                  <a:srgbClr val="000000"/>
-                </a:solidFill>
-                <a:latin typeface="Arial"/>
-                <a:ea typeface="Arial"/>
-                <a:cs typeface="Arial"/>
-              </a:defRPr>
-            </a:pPr>
-            <a:r>
-              <a:rPr sz="1725" b="0">
+              <a:defRPr sz="1400" b="0">
+                <a:solidFill>
+                  <a:srgbClr val="000000"/>
+                </a:solidFill>
+                <a:latin typeface="Arial"/>
+                <a:ea typeface="Arial"/>
+                <a:cs typeface="Arial"/>
+              </a:defRPr>
+            </a:pPr>
+            <a:r>
+              <a:rPr sz="1400" b="0">
                 <a:solidFill>
                   <a:srgbClr val="000000"/>
                 </a:solidFill>
@@ -5540,17 +5540,17 @@
           <a:p xmlns:a="http://schemas.openxmlformats.org/drawingml/2006/main">
             <a:pPr algn="l">
               <a:buNone/>
-              <a:defRPr sz="1725" b="0">
-                <a:solidFill>
-                  <a:srgbClr val="000000"/>
-                </a:solidFill>
-                <a:latin typeface="Arial"/>
-                <a:ea typeface="Arial"/>
-                <a:cs typeface="Arial"/>
-              </a:defRPr>
-            </a:pPr>
-            <a:r>
-              <a:rPr sz="1725" b="0">
+              <a:defRPr sz="1400" b="0">
+                <a:solidFill>
+                  <a:srgbClr val="000000"/>
+                </a:solidFill>
+                <a:latin typeface="Arial"/>
+                <a:ea typeface="Arial"/>
+                <a:cs typeface="Arial"/>
+              </a:defRPr>
+            </a:pPr>
+            <a:r>
+              <a:rPr sz="1400" b="0">
                 <a:solidFill>
                   <a:srgbClr val="000000"/>
                 </a:solidFill>
@@ -5579,8 +5579,8 @@
         </p:nvSpPr>
         <p:spPr>
           <a:xfrm xmlns:a="http://schemas.openxmlformats.org/drawingml/2006/main">
-            <a:off x="4476750" y="3714750"/>
-            <a:ext cx="2857500" cy="381000"/>
+            <a:off x="3590925" y="3714750"/>
+            <a:ext cx="2276475" cy="381000"/>
           </a:xfrm>
           <a:prstGeom xmlns:a="http://schemas.openxmlformats.org/drawingml/2006/main" prst="rect">
             <a:avLst/>
@@ -5597,17 +5597,17 @@
           <a:p xmlns:a="http://schemas.openxmlformats.org/drawingml/2006/main">
             <a:pPr algn="l">
               <a:buNone/>
-              <a:defRPr sz="2025" b="1">
-                <a:solidFill>
-                  <a:srgbClr val="000000"/>
-                </a:solidFill>
-                <a:latin typeface="Arial"/>
-                <a:ea typeface="Arial"/>
-                <a:cs typeface="Arial"/>
-              </a:defRPr>
-            </a:pPr>
-            <a:r>
-              <a:rPr sz="2025" b="1">
+              <a:defRPr sz="1500" b="1">
+                <a:solidFill>
+                  <a:srgbClr val="000000"/>
+                </a:solidFill>
+                <a:latin typeface="Arial"/>
+                <a:ea typeface="Arial"/>
+                <a:cs typeface="Arial"/>
+              </a:defRPr>
+            </a:pPr>
+            <a:r>
+              <a:rPr sz="1500" b="1">
                 <a:solidFill>
                   <a:srgbClr val="000000"/>
                 </a:solidFill>
@@ -5636,8 +5636,8 @@
         </p:nvSpPr>
         <p:spPr>
           <a:xfrm xmlns:a="http://schemas.openxmlformats.org/drawingml/2006/main">
-            <a:off x="4476750" y="4210050"/>
-            <a:ext cx="2857500" cy="1143000"/>
+            <a:off x="3590925" y="4210050"/>
+            <a:ext cx="2276475" cy="1400175"/>
           </a:xfrm>
           <a:prstGeom xmlns:a="http://schemas.openxmlformats.org/drawingml/2006/main" prst="rect">
             <a:avLst/>
@@ -5654,17 +5654,17 @@
           <a:p xmlns:a="http://schemas.openxmlformats.org/drawingml/2006/main">
             <a:pPr algn="l">
               <a:buNone/>
-              <a:defRPr sz="1725" b="0">
-                <a:solidFill>
-                  <a:srgbClr val="000000"/>
-                </a:solidFill>
-                <a:latin typeface="Arial"/>
-                <a:ea typeface="Arial"/>
-                <a:cs typeface="Arial"/>
-              </a:defRPr>
-            </a:pPr>
-            <a:r>
-              <a:rPr sz="1725" b="0">
+              <a:defRPr sz="1400" b="0">
+                <a:solidFill>
+                  <a:srgbClr val="000000"/>
+                </a:solidFill>
+                <a:latin typeface="Arial"/>
+                <a:ea typeface="Arial"/>
+                <a:cs typeface="Arial"/>
+              </a:defRPr>
+            </a:pPr>
+            <a:r>
+              <a:rPr sz="1400" b="0">
                 <a:solidFill>
                   <a:srgbClr val="000000"/>
                 </a:solidFill>
@@ -5678,17 +5678,17 @@
           <a:p xmlns:a="http://schemas.openxmlformats.org/drawingml/2006/main">
             <a:pPr algn="l">
               <a:buNone/>
-              <a:defRPr sz="1725" b="0">
-                <a:solidFill>
-                  <a:srgbClr val="000000"/>
-                </a:solidFill>
-                <a:latin typeface="Arial"/>
-                <a:ea typeface="Arial"/>
-                <a:cs typeface="Arial"/>
-              </a:defRPr>
-            </a:pPr>
-            <a:r>
-              <a:rPr sz="1725" b="0">
+              <a:defRPr sz="1400" b="0">
+                <a:solidFill>
+                  <a:srgbClr val="000000"/>
+                </a:solidFill>
+                <a:latin typeface="Arial"/>
+                <a:ea typeface="Arial"/>
+                <a:cs typeface="Arial"/>
+              </a:defRPr>
+            </a:pPr>
+            <a:r>
+              <a:rPr sz="1400" b="0">
                 <a:solidFill>
                   <a:srgbClr val="000000"/>
                 </a:solidFill>
@@ -5702,17 +5702,17 @@
           <a:p xmlns:a="http://schemas.openxmlformats.org/drawingml/2006/main">
             <a:pPr algn="l">
               <a:buNone/>
-              <a:defRPr sz="1725" b="0">
-                <a:solidFill>
-                  <a:srgbClr val="000000"/>
-                </a:solidFill>
-                <a:latin typeface="Arial"/>
-                <a:ea typeface="Arial"/>
-                <a:cs typeface="Arial"/>
-              </a:defRPr>
-            </a:pPr>
-            <a:r>
-              <a:rPr sz="1725" b="0">
+              <a:defRPr sz="1400" b="0">
+                <a:solidFill>
+                  <a:srgbClr val="000000"/>
+                </a:solidFill>
+                <a:latin typeface="Arial"/>
+                <a:ea typeface="Arial"/>
+                <a:cs typeface="Arial"/>
+              </a:defRPr>
+            </a:pPr>
+            <a:r>
+              <a:rPr sz="1400" b="0">
                 <a:solidFill>
                   <a:srgbClr val="000000"/>
                 </a:solidFill>
@@ -5741,8 +5741,8 @@
         </p:nvSpPr>
         <p:spPr>
           <a:xfrm xmlns:a="http://schemas.openxmlformats.org/drawingml/2006/main">
-            <a:off x="8096250" y="3714750"/>
-            <a:ext cx="3143250" cy="381000"/>
+            <a:off x="6324600" y="3714750"/>
+            <a:ext cx="2276475" cy="381000"/>
           </a:xfrm>
           <a:prstGeom xmlns:a="http://schemas.openxmlformats.org/drawingml/2006/main" prst="rect">
             <a:avLst/>
@@ -5759,17 +5759,17 @@
           <a:p xmlns:a="http://schemas.openxmlformats.org/drawingml/2006/main">
             <a:pPr algn="l">
               <a:buNone/>
-              <a:defRPr sz="2025" b="1">
-                <a:solidFill>
-                  <a:srgbClr val="000000"/>
-                </a:solidFill>
-                <a:latin typeface="Arial"/>
-                <a:ea typeface="Arial"/>
-                <a:cs typeface="Arial"/>
-              </a:defRPr>
-            </a:pPr>
-            <a:r>
-              <a:rPr sz="2025" b="1">
+              <a:defRPr sz="1500" b="1">
+                <a:solidFill>
+                  <a:srgbClr val="000000"/>
+                </a:solidFill>
+                <a:latin typeface="Arial"/>
+                <a:ea typeface="Arial"/>
+                <a:cs typeface="Arial"/>
+              </a:defRPr>
+            </a:pPr>
+            <a:r>
+              <a:rPr sz="1500" b="1">
                 <a:solidFill>
                   <a:srgbClr val="000000"/>
                 </a:solidFill>
@@ -5798,8 +5798,8 @@
         </p:nvSpPr>
         <p:spPr>
           <a:xfrm xmlns:a="http://schemas.openxmlformats.org/drawingml/2006/main">
-            <a:off x="8096250" y="4210050"/>
-            <a:ext cx="3238500" cy="1200150"/>
+            <a:off x="6324600" y="4210050"/>
+            <a:ext cx="2276475" cy="1400175"/>
           </a:xfrm>
           <a:prstGeom xmlns:a="http://schemas.openxmlformats.org/drawingml/2006/main" prst="rect">
             <a:avLst/>
@@ -5816,17 +5816,17 @@
           <a:p xmlns:a="http://schemas.openxmlformats.org/drawingml/2006/main">
             <a:pPr algn="l">
               <a:buNone/>
-              <a:defRPr sz="1725" b="0">
-                <a:solidFill>
-                  <a:srgbClr val="000000"/>
-                </a:solidFill>
-                <a:latin typeface="Arial"/>
-                <a:ea typeface="Arial"/>
-                <a:cs typeface="Arial"/>
-              </a:defRPr>
-            </a:pPr>
-            <a:r>
-              <a:rPr sz="1725" b="0">
+              <a:defRPr sz="1400" b="0">
+                <a:solidFill>
+                  <a:srgbClr val="000000"/>
+                </a:solidFill>
+                <a:latin typeface="Arial"/>
+                <a:ea typeface="Arial"/>
+                <a:cs typeface="Arial"/>
+              </a:defRPr>
+            </a:pPr>
+            <a:r>
+              <a:rPr sz="1400" b="0">
                 <a:solidFill>
                   <a:srgbClr val="000000"/>
                 </a:solidFill>
@@ -5840,17 +5840,17 @@
           <a:p xmlns:a="http://schemas.openxmlformats.org/drawingml/2006/main">
             <a:pPr algn="l">
               <a:buNone/>
-              <a:defRPr sz="1725" b="0">
-                <a:solidFill>
-                  <a:srgbClr val="000000"/>
-                </a:solidFill>
-                <a:latin typeface="Arial"/>
-                <a:ea typeface="Arial"/>
-                <a:cs typeface="Arial"/>
-              </a:defRPr>
-            </a:pPr>
-            <a:r>
-              <a:rPr sz="1725" b="0">
+              <a:defRPr sz="1400" b="0">
+                <a:solidFill>
+                  <a:srgbClr val="000000"/>
+                </a:solidFill>
+                <a:latin typeface="Arial"/>
+                <a:ea typeface="Arial"/>
+                <a:cs typeface="Arial"/>
+              </a:defRPr>
+            </a:pPr>
+            <a:r>
+              <a:rPr sz="1400" b="0">
                 <a:solidFill>
                   <a:srgbClr val="000000"/>
                 </a:solidFill>
@@ -5864,17 +5864,17 @@
           <a:p xmlns:a="http://schemas.openxmlformats.org/drawingml/2006/main">
             <a:pPr algn="l">
               <a:buNone/>
-              <a:defRPr sz="1725" b="0">
-                <a:solidFill>
-                  <a:srgbClr val="000000"/>
-                </a:solidFill>
-                <a:latin typeface="Arial"/>
-                <a:ea typeface="Arial"/>
-                <a:cs typeface="Arial"/>
-              </a:defRPr>
-            </a:pPr>
-            <a:r>
-              <a:rPr sz="1725" b="0">
+              <a:defRPr sz="1400" b="0">
+                <a:solidFill>
+                  <a:srgbClr val="000000"/>
+                </a:solidFill>
+                <a:latin typeface="Arial"/>
+                <a:ea typeface="Arial"/>
+                <a:cs typeface="Arial"/>
+              </a:defRPr>
+            </a:pPr>
+            <a:r>
+              <a:rPr sz="1400" b="0">
                 <a:solidFill>
                   <a:srgbClr val="000000"/>
                 </a:solidFill>
@@ -5883,6 +5883,258 @@
                 <a:cs typeface="Arial"/>
               </a:rPr>
               <a:t>Explicit thread boundaries</a:t>
+            </a:r>
+          </a:p>
+        </p:txBody>
+      </p:sp>
+      <p:sp>
+        <p:nvSpPr>
+          <p:cNvPr id="18" name="">
+            <a:extLst xmlns:a="http://schemas.openxmlformats.org/drawingml/2006/main">
+              <a:ext uri="{FF2B5EF4-FFF2-40B4-BE49-F238E27FC236}">
+                <a16:creationId xmlns:a16="http://schemas.microsoft.com/office/drawing/2014/main" id="{DB24BBD5-2EEA-418D-8B7A-6ACDDEFA210B}"/>
+              </a:ext>
+            </a:extLst>
+          </p:cNvPr>
+          <p:cNvSpPr>
+            <a:spLocks xmlns:a="http://schemas.openxmlformats.org/drawingml/2006/main" noGrp="1"/>
+          </p:cNvSpPr>
+          <p:nvPr/>
+        </p:nvSpPr>
+        <p:spPr>
+          <a:xfrm xmlns:a="http://schemas.openxmlformats.org/drawingml/2006/main">
+            <a:off x="9058275" y="3124200"/>
+            <a:ext cx="190500" cy="190500"/>
+          </a:xfrm>
+          <a:prstGeom xmlns:a="http://schemas.openxmlformats.org/drawingml/2006/main" prst="ellipse">
+            <a:avLst/>
+          </a:prstGeom>
+          <a:solidFill xmlns:a="http://schemas.openxmlformats.org/drawingml/2006/main">
+            <a:srgbClr val="3D8DFF"/>
+          </a:solidFill>
+          <a:ln xmlns:a="http://schemas.openxmlformats.org/drawingml/2006/main" w="0">
+            <a:solidFill>
+              <a:srgbClr val="3D8DFF"/>
+            </a:solidFill>
+            <a:prstDash val="solid"/>
+          </a:ln>
+        </p:spPr>
+      </p:sp>
+      <p:sp>
+        <p:nvSpPr>
+          <p:cNvPr id="19" name="roadmap-label-4">
+            <a:extLst xmlns:a="http://schemas.openxmlformats.org/drawingml/2006/main">
+              <a:ext uri="{FF2B5EF4-FFF2-40B4-BE49-F238E27FC236}">
+                <a16:creationId xmlns:a16="http://schemas.microsoft.com/office/drawing/2014/main" id="{21D281CB-99AE-455F-A094-80EAA9930804}"/>
+              </a:ext>
+            </a:extLst>
+          </p:cNvPr>
+          <p:cNvSpPr>
+            <a:spLocks xmlns:a="http://schemas.openxmlformats.org/drawingml/2006/main" noGrp="1"/>
+          </p:cNvSpPr>
+          <p:nvPr/>
+        </p:nvSpPr>
+        <p:spPr>
+          <a:xfrm xmlns:a="http://schemas.openxmlformats.org/drawingml/2006/main">
+            <a:off x="9058275" y="2628900"/>
+            <a:ext cx="1714500" cy="285750"/>
+          </a:xfrm>
+          <a:prstGeom xmlns:a="http://schemas.openxmlformats.org/drawingml/2006/main" prst="rect">
+            <a:avLst/>
+          </a:prstGeom>
+          <a:noFill xmlns:a="http://schemas.openxmlformats.org/drawingml/2006/main"/>
+          <a:ln xmlns:a="http://schemas.openxmlformats.org/drawingml/2006/main" w="0">
+            <a:noFill/>
+            <a:prstDash val="solid"/>
+          </a:ln>
+        </p:spPr>
+        <p:txBody>
+          <a:bodyPr xmlns:a="http://schemas.openxmlformats.org/drawingml/2006/main" anchor="t"/>
+          <a:lstStyle xmlns:a="http://schemas.openxmlformats.org/drawingml/2006/main"/>
+          <a:p xmlns:a="http://schemas.openxmlformats.org/drawingml/2006/main">
+            <a:pPr algn="l">
+              <a:buNone/>
+              <a:defRPr sz="1500" b="1">
+                <a:solidFill>
+                  <a:srgbClr val="62666D"/>
+                </a:solidFill>
+                <a:latin typeface="Arial"/>
+                <a:ea typeface="Arial"/>
+                <a:cs typeface="Arial"/>
+              </a:defRPr>
+            </a:pPr>
+            <a:r>
+              <a:rPr sz="1500" b="1">
+                <a:solidFill>
+                  <a:srgbClr val="62666D"/>
+                </a:solidFill>
+                <a:latin typeface="Arial"/>
+                <a:ea typeface="Arial"/>
+                <a:cs typeface="Arial"/>
+              </a:rPr>
+              <a:t>ACCEPTED</a:t>
+            </a:r>
+          </a:p>
+        </p:txBody>
+      </p:sp>
+      <p:sp>
+        <p:nvSpPr>
+          <p:cNvPr id="20" name="roadmap-title-4">
+            <a:extLst xmlns:a="http://schemas.openxmlformats.org/drawingml/2006/main">
+              <a:ext uri="{FF2B5EF4-FFF2-40B4-BE49-F238E27FC236}">
+                <a16:creationId xmlns:a16="http://schemas.microsoft.com/office/drawing/2014/main" id="{5342E703-F985-4E5C-B488-25379A11F16C}"/>
+              </a:ext>
+            </a:extLst>
+          </p:cNvPr>
+          <p:cNvSpPr>
+            <a:spLocks xmlns:a="http://schemas.openxmlformats.org/drawingml/2006/main" noGrp="1"/>
+          </p:cNvSpPr>
+          <p:nvPr/>
+        </p:nvSpPr>
+        <p:spPr>
+          <a:xfrm xmlns:a="http://schemas.openxmlformats.org/drawingml/2006/main">
+            <a:off x="9058275" y="3714750"/>
+            <a:ext cx="2276475" cy="381000"/>
+          </a:xfrm>
+          <a:prstGeom xmlns:a="http://schemas.openxmlformats.org/drawingml/2006/main" prst="rect">
+            <a:avLst/>
+          </a:prstGeom>
+          <a:noFill xmlns:a="http://schemas.openxmlformats.org/drawingml/2006/main"/>
+          <a:ln xmlns:a="http://schemas.openxmlformats.org/drawingml/2006/main" w="0">
+            <a:noFill/>
+            <a:prstDash val="solid"/>
+          </a:ln>
+        </p:spPr>
+        <p:txBody>
+          <a:bodyPr xmlns:a="http://schemas.openxmlformats.org/drawingml/2006/main" anchor="t"/>
+          <a:lstStyle xmlns:a="http://schemas.openxmlformats.org/drawingml/2006/main"/>
+          <a:p xmlns:a="http://schemas.openxmlformats.org/drawingml/2006/main">
+            <a:pPr algn="l">
+              <a:buNone/>
+              <a:defRPr sz="1500" b="1">
+                <a:solidFill>
+                  <a:srgbClr val="000000"/>
+                </a:solidFill>
+                <a:latin typeface="Arial"/>
+                <a:ea typeface="Arial"/>
+                <a:cs typeface="Arial"/>
+              </a:defRPr>
+            </a:pPr>
+            <a:r>
+              <a:rPr sz="1500" b="1">
+                <a:solidFill>
+                  <a:srgbClr val="000000"/>
+                </a:solidFill>
+                <a:latin typeface="Arial"/>
+                <a:ea typeface="Arial"/>
+                <a:cs typeface="Arial"/>
+              </a:rPr>
+              <a:t>Identity + UI</a:t>
+            </a:r>
+          </a:p>
+        </p:txBody>
+      </p:sp>
+      <p:sp>
+        <p:nvSpPr>
+          <p:cNvPr id="21" name="roadmap-body-4">
+            <a:extLst xmlns:a="http://schemas.openxmlformats.org/drawingml/2006/main">
+              <a:ext uri="{FF2B5EF4-FFF2-40B4-BE49-F238E27FC236}">
+                <a16:creationId xmlns:a16="http://schemas.microsoft.com/office/drawing/2014/main" id="{53FDC37D-6B00-4C16-9A94-9EBB849C23DF}"/>
+              </a:ext>
+            </a:extLst>
+          </p:cNvPr>
+          <p:cNvSpPr>
+            <a:spLocks xmlns:a="http://schemas.openxmlformats.org/drawingml/2006/main" noGrp="1"/>
+          </p:cNvSpPr>
+          <p:nvPr/>
+        </p:nvSpPr>
+        <p:spPr>
+          <a:xfrm xmlns:a="http://schemas.openxmlformats.org/drawingml/2006/main">
+            <a:off x="9058275" y="4210050"/>
+            <a:ext cx="2276475" cy="1400175"/>
+          </a:xfrm>
+          <a:prstGeom xmlns:a="http://schemas.openxmlformats.org/drawingml/2006/main" prst="rect">
+            <a:avLst/>
+          </a:prstGeom>
+          <a:noFill xmlns:a="http://schemas.openxmlformats.org/drawingml/2006/main"/>
+          <a:ln xmlns:a="http://schemas.openxmlformats.org/drawingml/2006/main" w="0">
+            <a:noFill/>
+            <a:prstDash val="solid"/>
+          </a:ln>
+        </p:spPr>
+        <p:txBody>
+          <a:bodyPr xmlns:a="http://schemas.openxmlformats.org/drawingml/2006/main" anchor="t"/>
+          <a:lstStyle xmlns:a="http://schemas.openxmlformats.org/drawingml/2006/main"/>
+          <a:p xmlns:a="http://schemas.openxmlformats.org/drawingml/2006/main">
+            <a:pPr algn="l">
+              <a:buNone/>
+              <a:defRPr sz="1400" b="0">
+                <a:solidFill>
+                  <a:srgbClr val="000000"/>
+                </a:solidFill>
+                <a:latin typeface="Arial"/>
+                <a:ea typeface="Arial"/>
+                <a:cs typeface="Arial"/>
+              </a:defRPr>
+            </a:pPr>
+            <a:r>
+              <a:rPr sz="1400" b="0">
+                <a:solidFill>
+                  <a:srgbClr val="000000"/>
+                </a:solidFill>
+                <a:latin typeface="Arial"/>
+                <a:ea typeface="Arial"/>
+                <a:cs typeface="Arial"/>
+              </a:rPr>
+              <a:t>ADR-006 + ADR-007 accepted</a:t>
+            </a:r>
+          </a:p>
+          <a:p xmlns:a="http://schemas.openxmlformats.org/drawingml/2006/main">
+            <a:pPr algn="l">
+              <a:buNone/>
+              <a:defRPr sz="1400" b="0">
+                <a:solidFill>
+                  <a:srgbClr val="000000"/>
+                </a:solidFill>
+                <a:latin typeface="Arial"/>
+                <a:ea typeface="Arial"/>
+                <a:cs typeface="Arial"/>
+              </a:defRPr>
+            </a:pPr>
+            <a:r>
+              <a:rPr sz="1400" b="0">
+                <a:solidFill>
+                  <a:srgbClr val="000000"/>
+                </a:solidFill>
+                <a:latin typeface="Arial"/>
+                <a:ea typeface="Arial"/>
+                <a:cs typeface="Arial"/>
+              </a:rPr>
+              <a:t>Explicit sequence identity</a:t>
+            </a:r>
+          </a:p>
+          <a:p xmlns:a="http://schemas.openxmlformats.org/drawingml/2006/main">
+            <a:pPr algn="l">
+              <a:buNone/>
+              <a:defRPr sz="1400" b="0">
+                <a:solidFill>
+                  <a:srgbClr val="000000"/>
+                </a:solidFill>
+                <a:latin typeface="Arial"/>
+                <a:ea typeface="Arial"/>
+                <a:cs typeface="Arial"/>
+              </a:defRPr>
+            </a:pPr>
+            <a:r>
+              <a:rPr sz="1400" b="0">
+                <a:solidFill>
+                  <a:srgbClr val="000000"/>
+                </a:solidFill>
+                <a:latin typeface="Arial"/>
+                <a:ea typeface="Arial"/>
+                <a:cs typeface="Arial"/>
+              </a:rPr>
+              <a:t>Framework-neutral adapters</a:t>
             </a:r>
           </a:p>
         </p:txBody>

</xml_diff>